<commit_message>
Insert "Where is Shizuoka?" slide (now 13 pages)
Add a provenance locator slide after Single-Origin Shizuoka: headline,
subhead, a stylized Mt. Fuji/Shizuoka locator (placeholder for a map image),
and four fact rows (location, tea heritage, terroir, name recognition).
Renumber following slides and update the content spec.

Co-Authored-By: Claude Opus 4.8 <noreply@anthropic.com>
Claude-Session: https://claude.ai/code/session_01FX28XCL3v6f7LuJT98rxVZ
</commit_message>
<xml_diff>
--- a/03_channels/b2b/SHIZUNE_MATCHA_B2B_Deck.pptx
+++ b/03_channels/b2b/SHIZUNE_MATCHA_B2B_Deck.pptx
@@ -17,9 +17,10 @@
     <p:sldId id="265" r:id="rId11"/>
     <p:sldId id="266" r:id="rId12"/>
     <p:sldId id="267" r:id="rId13"/>
+    <p:sldId id="268" r:id="rId14"/>
   </p:sldIdLst>
   <p:notesMasterIdLst>
-    <p:notesMasterId r:id="rId14"/>
+    <p:notesMasterId r:id="rId15"/>
   </p:notesMasterIdLst>
   <p:sldSz cx="12192000" cy="6858000"/>
   <p:notesSz cx="6858000" cy="12192000"/>
@@ -801,6 +802,94 @@
             <a:fld id="{F7021451-1387-4CA6-816F-3879F97B5CBC}" type="slidenum">
               <a:rPr lang="en-US"/>
               <a:t>12</a:t>
+            </a:fld>
+            <a:endParaRPr lang="en-US"/>
+          </a:p>
+        </p:txBody>
+      </p:sp>
+    </p:spTree>
+    <p:extLst>
+      <p:ext uri="{BB962C8B-B14F-4D97-AF65-F5344CB8AC3E}">
+        <p14:creationId xmlns:p14="http://schemas.microsoft.com/office/powerpoint/2010/main" val="1024086991"/>
+      </p:ext>
+    </p:extLst>
+  </p:cSld>
+  <p:clrMapOvr>
+    <a:masterClrMapping/>
+  </p:clrMapOvr>
+</p:notes>
+</file>
+
+<file path=ppt/notesSlides/notesSlide13.xml><?xml version="1.0" encoding="utf-8"?>
+<p:notes xmlns:a="http://schemas.openxmlformats.org/drawingml/2006/main" xmlns:r="http://schemas.openxmlformats.org/officeDocument/2006/relationships" xmlns:p="http://schemas.openxmlformats.org/presentationml/2006/main">
+  <p:cSld>
+    <p:spTree>
+      <p:nvGrpSpPr>
+        <p:cNvPr id="1" name=""/>
+        <p:cNvGrpSpPr/>
+        <p:nvPr/>
+      </p:nvGrpSpPr>
+      <p:grpSpPr>
+        <a:xfrm>
+          <a:off x="0" y="0"/>
+          <a:ext cx="0" cy="0"/>
+          <a:chOff x="0" y="0"/>
+          <a:chExt cx="0" cy="0"/>
+        </a:xfrm>
+      </p:grpSpPr>
+      <p:sp>
+        <p:nvSpPr>
+          <p:cNvPr id="2" name="Slide Image Placeholder 1"/>
+          <p:cNvSpPr>
+            <a:spLocks noGrp="1" noRot="1" noChangeAspect="1"/>
+          </p:cNvSpPr>
+          <p:nvPr>
+            <p:ph type="sldImg"/>
+          </p:nvPr>
+        </p:nvSpPr>
+        <p:spPr/>
+      </p:sp>
+      <p:sp>
+        <p:nvSpPr>
+          <p:cNvPr id="3" name="Notes Placeholder 2"/>
+          <p:cNvSpPr>
+            <a:spLocks noGrp="1"/>
+          </p:cNvSpPr>
+          <p:nvPr>
+            <p:ph type="body" idx="1"/>
+          </p:nvPr>
+        </p:nvSpPr>
+        <p:spPr/>
+        <p:txBody>
+          <a:bodyPr/>
+          <a:lstStyle/>
+          <a:p>
+            <a:r>
+              <a:rPr lang="en-US" dirty="0"/>
+              <a:t/>
+            </a:r>
+            <a:endParaRPr lang="en-US" dirty="0"/>
+          </a:p>
+        </p:txBody>
+      </p:sp>
+      <p:sp>
+        <p:nvSpPr>
+          <p:cNvPr id="4" name="Slide Number Placeholder 3"/>
+          <p:cNvSpPr>
+            <a:spLocks noGrp="1"/>
+          </p:cNvSpPr>
+          <p:nvPr>
+            <p:ph type="sldNum" sz="quarter" idx="10"/>
+          </p:nvPr>
+        </p:nvSpPr>
+        <p:spPr/>
+        <p:txBody>
+          <a:bodyPr/>
+          <a:lstStyle/>
+          <a:p>
+            <a:fld id="{F7021451-1387-4CA6-816F-3879F97B5CBC}" type="slidenum">
+              <a:rPr lang="en-US"/>
+              <a:t>13</a:t>
             </a:fld>
             <a:endParaRPr lang="en-US"/>
           </a:p>
@@ -2158,6 +2247,1276 @@
     <p:bg>
       <p:bgPr>
         <a:solidFill>
+          <a:srgbClr val="FFFFFF"/>
+        </a:solidFill>
+      </p:bgPr>
+    </p:bg>
+    <p:spTree>
+      <p:nvGrpSpPr>
+        <p:cNvPr id="1" name=""/>
+        <p:cNvGrpSpPr/>
+        <p:nvPr/>
+      </p:nvGrpSpPr>
+      <p:grpSpPr>
+        <a:xfrm>
+          <a:off x="0" y="0"/>
+          <a:ext cx="0" cy="0"/>
+          <a:chOff x="0" y="0"/>
+          <a:chExt cx="0" cy="0"/>
+        </a:xfrm>
+      </p:grpSpPr>
+      <p:sp>
+        <p:nvSpPr>
+          <p:cNvPr id="2" name="Shape 0"/>
+          <p:cNvSpPr/>
+          <p:nvPr/>
+        </p:nvSpPr>
+        <p:spPr>
+          <a:xfrm>
+            <a:off x="640080" y="667512"/>
+            <a:ext cx="109728" cy="109728"/>
+          </a:xfrm>
+          <a:prstGeom prst="ellipse">
+            <a:avLst/>
+          </a:prstGeom>
+          <a:solidFill>
+            <a:srgbClr val="5E7A3C"/>
+          </a:solidFill>
+          <a:ln/>
+        </p:spPr>
+      </p:sp>
+      <p:sp>
+        <p:nvSpPr>
+          <p:cNvPr id="3" name="Text 1"/>
+          <p:cNvSpPr/>
+          <p:nvPr/>
+        </p:nvSpPr>
+        <p:spPr>
+          <a:xfrm>
+            <a:off x="841248" y="603504"/>
+            <a:ext cx="5486400" cy="256032"/>
+          </a:xfrm>
+          <a:prstGeom prst="rect">
+            <a:avLst/>
+          </a:prstGeom>
+          <a:noFill/>
+          <a:ln/>
+        </p:spPr>
+        <p:txBody>
+          <a:bodyPr wrap="square" rtlCol="0" anchor="ctr"/>
+          <a:lstStyle/>
+          <a:p>
+            <a:pPr algn="l" indent="0" marL="0">
+              <a:buNone/>
+            </a:pPr>
+            <a:r>
+              <a:rPr lang="en-US" sz="1100" b="1" spc="200" kern="0" dirty="0">
+                <a:solidFill>
+                  <a:srgbClr val="5E7A3C"/>
+                </a:solidFill>
+                <a:latin typeface="Calibri" pitchFamily="34" charset="0"/>
+                <a:ea typeface="Calibri" pitchFamily="34" charset="-122"/>
+                <a:cs typeface="Calibri" pitchFamily="34" charset="-120"/>
+              </a:rPr>
+              <a:t>WHOLESALE TERMS</a:t>
+            </a:r>
+            <a:endParaRPr lang="en-US" sz="1100" dirty="0"/>
+          </a:p>
+        </p:txBody>
+      </p:sp>
+      <p:sp>
+        <p:nvSpPr>
+          <p:cNvPr id="4" name="Text 2"/>
+          <p:cNvSpPr/>
+          <p:nvPr/>
+        </p:nvSpPr>
+        <p:spPr>
+          <a:xfrm>
+            <a:off x="10820095" y="502920"/>
+            <a:ext cx="731520" cy="274320"/>
+          </a:xfrm>
+          <a:prstGeom prst="rect">
+            <a:avLst/>
+          </a:prstGeom>
+          <a:noFill/>
+          <a:ln/>
+        </p:spPr>
+        <p:txBody>
+          <a:bodyPr wrap="square" rtlCol="0" anchor="ctr"/>
+          <a:lstStyle/>
+          <a:p>
+            <a:pPr algn="r" indent="0" marL="0">
+              <a:buNone/>
+            </a:pPr>
+            <a:r>
+              <a:rPr lang="en-US" sz="1000" b="1" dirty="0">
+                <a:solidFill>
+                  <a:srgbClr val="9DAE86"/>
+                </a:solidFill>
+                <a:latin typeface="Calibri" pitchFamily="34" charset="0"/>
+                <a:ea typeface="Calibri" pitchFamily="34" charset="-122"/>
+                <a:cs typeface="Calibri" pitchFamily="34" charset="-120"/>
+              </a:rPr>
+              <a:t>10</a:t>
+            </a:r>
+            <a:endParaRPr lang="en-US" sz="1000" dirty="0"/>
+          </a:p>
+        </p:txBody>
+      </p:sp>
+      <p:sp>
+        <p:nvSpPr>
+          <p:cNvPr id="5" name="Text 3"/>
+          <p:cNvSpPr/>
+          <p:nvPr/>
+        </p:nvSpPr>
+        <p:spPr>
+          <a:xfrm>
+            <a:off x="640080" y="1097280"/>
+            <a:ext cx="10515600" cy="640080"/>
+          </a:xfrm>
+          <a:prstGeom prst="rect">
+            <a:avLst/>
+          </a:prstGeom>
+          <a:noFill/>
+          <a:ln/>
+        </p:spPr>
+        <p:txBody>
+          <a:bodyPr wrap="square" rtlCol="0" anchor="ctr"/>
+          <a:lstStyle/>
+          <a:p>
+            <a:pPr indent="0" marL="0">
+              <a:buNone/>
+            </a:pPr>
+            <a:r>
+              <a:rPr lang="en-US" sz="3400" dirty="0">
+                <a:solidFill>
+                  <a:srgbClr val="2C332A"/>
+                </a:solidFill>
+                <a:latin typeface="Cambria" pitchFamily="34" charset="0"/>
+                <a:ea typeface="Cambria" pitchFamily="34" charset="-122"/>
+                <a:cs typeface="Cambria" pitchFamily="34" charset="-120"/>
+              </a:rPr>
+              <a:t>Simple terms to get started.</a:t>
+            </a:r>
+            <a:endParaRPr lang="en-US" sz="3400" dirty="0"/>
+          </a:p>
+        </p:txBody>
+      </p:sp>
+      <p:sp>
+        <p:nvSpPr>
+          <p:cNvPr id="6" name="Shape 4"/>
+          <p:cNvSpPr/>
+          <p:nvPr/>
+        </p:nvSpPr>
+        <p:spPr>
+          <a:xfrm>
+            <a:off x="640080" y="1920240"/>
+            <a:ext cx="5227168" cy="1188720"/>
+          </a:xfrm>
+          <a:prstGeom prst="roundRect">
+            <a:avLst>
+              <a:gd name="adj" fmla="val 6154"/>
+            </a:avLst>
+          </a:prstGeom>
+          <a:solidFill>
+            <a:srgbClr val="F6F4EC"/>
+          </a:solidFill>
+          <a:ln w="12700">
+            <a:solidFill>
+              <a:srgbClr val="E2DFD4"/>
+            </a:solidFill>
+            <a:prstDash val="solid"/>
+          </a:ln>
+        </p:spPr>
+      </p:sp>
+      <p:sp>
+        <p:nvSpPr>
+          <p:cNvPr id="7" name="Shape 5"/>
+          <p:cNvSpPr/>
+          <p:nvPr/>
+        </p:nvSpPr>
+        <p:spPr>
+          <a:xfrm>
+            <a:off x="960120" y="2240280"/>
+            <a:ext cx="566928" cy="566928"/>
+          </a:xfrm>
+          <a:prstGeom prst="ellipse">
+            <a:avLst/>
+          </a:prstGeom>
+          <a:solidFill>
+            <a:srgbClr val="5E7A3C"/>
+          </a:solidFill>
+          <a:ln/>
+        </p:spPr>
+      </p:sp>
+      <p:sp>
+        <p:nvSpPr>
+          <p:cNvPr id="8" name="Text 6"/>
+          <p:cNvSpPr/>
+          <p:nvPr/>
+        </p:nvSpPr>
+        <p:spPr>
+          <a:xfrm>
+            <a:off x="960120" y="2240280"/>
+            <a:ext cx="566928" cy="566928"/>
+          </a:xfrm>
+          <a:prstGeom prst="rect">
+            <a:avLst/>
+          </a:prstGeom>
+          <a:noFill/>
+          <a:ln/>
+        </p:spPr>
+        <p:txBody>
+          <a:bodyPr wrap="square" rtlCol="0" anchor="ctr"/>
+          <a:lstStyle/>
+          <a:p>
+            <a:pPr algn="ctr" indent="0" marL="0">
+              <a:buNone/>
+            </a:pPr>
+            <a:r>
+              <a:rPr lang="en-US" sz="2200" b="1" dirty="0">
+                <a:solidFill>
+                  <a:srgbClr val="FFFFFF"/>
+                </a:solidFill>
+                <a:latin typeface="Cambria" pitchFamily="34" charset="0"/>
+                <a:ea typeface="Cambria" pitchFamily="34" charset="-122"/>
+                <a:cs typeface="Cambria" pitchFamily="34" charset="-120"/>
+              </a:rPr>
+              <a:t>M</a:t>
+            </a:r>
+            <a:endParaRPr lang="en-US" sz="2200" dirty="0"/>
+          </a:p>
+        </p:txBody>
+      </p:sp>
+      <p:sp>
+        <p:nvSpPr>
+          <p:cNvPr id="9" name="Text 7"/>
+          <p:cNvSpPr/>
+          <p:nvPr/>
+        </p:nvSpPr>
+        <p:spPr>
+          <a:xfrm>
+            <a:off x="1737360" y="2139696"/>
+            <a:ext cx="3947008" cy="320040"/>
+          </a:xfrm>
+          <a:prstGeom prst="rect">
+            <a:avLst/>
+          </a:prstGeom>
+          <a:noFill/>
+          <a:ln/>
+        </p:spPr>
+        <p:txBody>
+          <a:bodyPr wrap="square" rtlCol="0" anchor="ctr"/>
+          <a:lstStyle/>
+          <a:p>
+            <a:pPr indent="0" marL="0">
+              <a:buNone/>
+            </a:pPr>
+            <a:r>
+              <a:rPr lang="en-US" sz="1250" b="1" spc="100" kern="0" dirty="0">
+                <a:solidFill>
+                  <a:srgbClr val="47602D"/>
+                </a:solidFill>
+                <a:latin typeface="Calibri" pitchFamily="34" charset="0"/>
+                <a:ea typeface="Calibri" pitchFamily="34" charset="-122"/>
+                <a:cs typeface="Calibri" pitchFamily="34" charset="-120"/>
+              </a:rPr>
+              <a:t>MOQ</a:t>
+            </a:r>
+            <a:endParaRPr lang="en-US" sz="1250" dirty="0"/>
+          </a:p>
+        </p:txBody>
+      </p:sp>
+      <p:sp>
+        <p:nvSpPr>
+          <p:cNvPr id="10" name="Text 8"/>
+          <p:cNvSpPr/>
+          <p:nvPr/>
+        </p:nvSpPr>
+        <p:spPr>
+          <a:xfrm>
+            <a:off x="1737360" y="2468880"/>
+            <a:ext cx="3901288" cy="594360"/>
+          </a:xfrm>
+          <a:prstGeom prst="rect">
+            <a:avLst/>
+          </a:prstGeom>
+          <a:noFill/>
+          <a:ln/>
+        </p:spPr>
+        <p:txBody>
+          <a:bodyPr wrap="square" rtlCol="0" anchor="t"/>
+          <a:lstStyle/>
+          <a:p>
+            <a:pPr indent="0" marL="0">
+              <a:buNone/>
+            </a:pPr>
+            <a:r>
+              <a:rPr lang="en-US" sz="1200" dirty="0">
+                <a:solidFill>
+                  <a:srgbClr val="2C332A"/>
+                </a:solidFill>
+                <a:latin typeface="Calibri" pitchFamily="34" charset="0"/>
+                <a:ea typeface="Calibri" pitchFamily="34" charset="-122"/>
+                <a:cs typeface="Calibri" pitchFamily="34" charset="-120"/>
+              </a:rPr>
+              <a:t>Bulk: 1 kg   ·   Finished SKUs: 3 cases (opening order)</a:t>
+            </a:r>
+            <a:endParaRPr lang="en-US" sz="1200" dirty="0"/>
+          </a:p>
+        </p:txBody>
+      </p:sp>
+      <p:sp>
+        <p:nvSpPr>
+          <p:cNvPr id="11" name="Shape 9"/>
+          <p:cNvSpPr/>
+          <p:nvPr/>
+        </p:nvSpPr>
+        <p:spPr>
+          <a:xfrm>
+            <a:off x="6324448" y="1920240"/>
+            <a:ext cx="5227168" cy="1188720"/>
+          </a:xfrm>
+          <a:prstGeom prst="roundRect">
+            <a:avLst>
+              <a:gd name="adj" fmla="val 6154"/>
+            </a:avLst>
+          </a:prstGeom>
+          <a:solidFill>
+            <a:srgbClr val="F6F4EC"/>
+          </a:solidFill>
+          <a:ln w="12700">
+            <a:solidFill>
+              <a:srgbClr val="E2DFD4"/>
+            </a:solidFill>
+            <a:prstDash val="solid"/>
+          </a:ln>
+        </p:spPr>
+      </p:sp>
+      <p:sp>
+        <p:nvSpPr>
+          <p:cNvPr id="12" name="Shape 10"/>
+          <p:cNvSpPr/>
+          <p:nvPr/>
+        </p:nvSpPr>
+        <p:spPr>
+          <a:xfrm>
+            <a:off x="6644488" y="2240280"/>
+            <a:ext cx="566928" cy="566928"/>
+          </a:xfrm>
+          <a:prstGeom prst="ellipse">
+            <a:avLst/>
+          </a:prstGeom>
+          <a:solidFill>
+            <a:srgbClr val="5E7A3C"/>
+          </a:solidFill>
+          <a:ln/>
+        </p:spPr>
+      </p:sp>
+      <p:sp>
+        <p:nvSpPr>
+          <p:cNvPr id="13" name="Text 11"/>
+          <p:cNvSpPr/>
+          <p:nvPr/>
+        </p:nvSpPr>
+        <p:spPr>
+          <a:xfrm>
+            <a:off x="6644488" y="2240280"/>
+            <a:ext cx="566928" cy="566928"/>
+          </a:xfrm>
+          <a:prstGeom prst="rect">
+            <a:avLst/>
+          </a:prstGeom>
+          <a:noFill/>
+          <a:ln/>
+        </p:spPr>
+        <p:txBody>
+          <a:bodyPr wrap="square" rtlCol="0" anchor="ctr"/>
+          <a:lstStyle/>
+          <a:p>
+            <a:pPr algn="ctr" indent="0" marL="0">
+              <a:buNone/>
+            </a:pPr>
+            <a:r>
+              <a:rPr lang="en-US" sz="2200" b="1" dirty="0">
+                <a:solidFill>
+                  <a:srgbClr val="FFFFFF"/>
+                </a:solidFill>
+                <a:latin typeface="Cambria" pitchFamily="34" charset="0"/>
+                <a:ea typeface="Cambria" pitchFamily="34" charset="-122"/>
+                <a:cs typeface="Cambria" pitchFamily="34" charset="-120"/>
+              </a:rPr>
+              <a:t>C</a:t>
+            </a:r>
+            <a:endParaRPr lang="en-US" sz="2200" dirty="0"/>
+          </a:p>
+        </p:txBody>
+      </p:sp>
+      <p:sp>
+        <p:nvSpPr>
+          <p:cNvPr id="14" name="Text 12"/>
+          <p:cNvSpPr/>
+          <p:nvPr/>
+        </p:nvSpPr>
+        <p:spPr>
+          <a:xfrm>
+            <a:off x="7421728" y="2139696"/>
+            <a:ext cx="3947008" cy="320040"/>
+          </a:xfrm>
+          <a:prstGeom prst="rect">
+            <a:avLst/>
+          </a:prstGeom>
+          <a:noFill/>
+          <a:ln/>
+        </p:spPr>
+        <p:txBody>
+          <a:bodyPr wrap="square" rtlCol="0" anchor="ctr"/>
+          <a:lstStyle/>
+          <a:p>
+            <a:pPr indent="0" marL="0">
+              <a:buNone/>
+            </a:pPr>
+            <a:r>
+              <a:rPr lang="en-US" sz="1250" b="1" spc="100" kern="0" dirty="0">
+                <a:solidFill>
+                  <a:srgbClr val="47602D"/>
+                </a:solidFill>
+                <a:latin typeface="Calibri" pitchFamily="34" charset="0"/>
+                <a:ea typeface="Calibri" pitchFamily="34" charset="-122"/>
+                <a:cs typeface="Calibri" pitchFamily="34" charset="-120"/>
+              </a:rPr>
+              <a:t>Case pack</a:t>
+            </a:r>
+            <a:endParaRPr lang="en-US" sz="1250" dirty="0"/>
+          </a:p>
+        </p:txBody>
+      </p:sp>
+      <p:sp>
+        <p:nvSpPr>
+          <p:cNvPr id="15" name="Text 13"/>
+          <p:cNvSpPr/>
+          <p:nvPr/>
+        </p:nvSpPr>
+        <p:spPr>
+          <a:xfrm>
+            <a:off x="7421728" y="2468880"/>
+            <a:ext cx="3901288" cy="594360"/>
+          </a:xfrm>
+          <a:prstGeom prst="rect">
+            <a:avLst/>
+          </a:prstGeom>
+          <a:noFill/>
+          <a:ln/>
+        </p:spPr>
+        <p:txBody>
+          <a:bodyPr wrap="square" rtlCol="0" anchor="t"/>
+          <a:lstStyle/>
+          <a:p>
+            <a:pPr indent="0" marL="0">
+              <a:buNone/>
+            </a:pPr>
+            <a:r>
+              <a:rPr lang="en-US" sz="1200" dirty="0">
+                <a:solidFill>
+                  <a:srgbClr val="2C332A"/>
+                </a:solidFill>
+                <a:latin typeface="Calibri" pitchFamily="34" charset="0"/>
+                <a:ea typeface="Calibri" pitchFamily="34" charset="-122"/>
+                <a:cs typeface="Calibri" pitchFamily="34" charset="-120"/>
+              </a:rPr>
+              <a:t>12 units per case</a:t>
+            </a:r>
+            <a:endParaRPr lang="en-US" sz="1200" dirty="0"/>
+          </a:p>
+        </p:txBody>
+      </p:sp>
+      <p:sp>
+        <p:nvSpPr>
+          <p:cNvPr id="16" name="Shape 14"/>
+          <p:cNvSpPr/>
+          <p:nvPr/>
+        </p:nvSpPr>
+        <p:spPr>
+          <a:xfrm>
+            <a:off x="640080" y="3364992"/>
+            <a:ext cx="5227168" cy="1188720"/>
+          </a:xfrm>
+          <a:prstGeom prst="roundRect">
+            <a:avLst>
+              <a:gd name="adj" fmla="val 6154"/>
+            </a:avLst>
+          </a:prstGeom>
+          <a:solidFill>
+            <a:srgbClr val="F6F4EC"/>
+          </a:solidFill>
+          <a:ln w="12700">
+            <a:solidFill>
+              <a:srgbClr val="E2DFD4"/>
+            </a:solidFill>
+            <a:prstDash val="solid"/>
+          </a:ln>
+        </p:spPr>
+      </p:sp>
+      <p:sp>
+        <p:nvSpPr>
+          <p:cNvPr id="17" name="Shape 15"/>
+          <p:cNvSpPr/>
+          <p:nvPr/>
+        </p:nvSpPr>
+        <p:spPr>
+          <a:xfrm>
+            <a:off x="960120" y="3685032"/>
+            <a:ext cx="566928" cy="566928"/>
+          </a:xfrm>
+          <a:prstGeom prst="ellipse">
+            <a:avLst/>
+          </a:prstGeom>
+          <a:solidFill>
+            <a:srgbClr val="5E7A3C"/>
+          </a:solidFill>
+          <a:ln/>
+        </p:spPr>
+      </p:sp>
+      <p:sp>
+        <p:nvSpPr>
+          <p:cNvPr id="18" name="Text 16"/>
+          <p:cNvSpPr/>
+          <p:nvPr/>
+        </p:nvSpPr>
+        <p:spPr>
+          <a:xfrm>
+            <a:off x="960120" y="3685032"/>
+            <a:ext cx="566928" cy="566928"/>
+          </a:xfrm>
+          <a:prstGeom prst="rect">
+            <a:avLst/>
+          </a:prstGeom>
+          <a:noFill/>
+          <a:ln/>
+        </p:spPr>
+        <p:txBody>
+          <a:bodyPr wrap="square" rtlCol="0" anchor="ctr"/>
+          <a:lstStyle/>
+          <a:p>
+            <a:pPr algn="ctr" indent="0" marL="0">
+              <a:buNone/>
+            </a:pPr>
+            <a:r>
+              <a:rPr lang="en-US" sz="2200" b="1" dirty="0">
+                <a:solidFill>
+                  <a:srgbClr val="FFFFFF"/>
+                </a:solidFill>
+                <a:latin typeface="Cambria" pitchFamily="34" charset="0"/>
+                <a:ea typeface="Cambria" pitchFamily="34" charset="-122"/>
+                <a:cs typeface="Cambria" pitchFamily="34" charset="-120"/>
+              </a:rPr>
+              <a:t>L</a:t>
+            </a:r>
+            <a:endParaRPr lang="en-US" sz="2200" dirty="0"/>
+          </a:p>
+        </p:txBody>
+      </p:sp>
+      <p:sp>
+        <p:nvSpPr>
+          <p:cNvPr id="19" name="Text 17"/>
+          <p:cNvSpPr/>
+          <p:nvPr/>
+        </p:nvSpPr>
+        <p:spPr>
+          <a:xfrm>
+            <a:off x="1737360" y="3584448"/>
+            <a:ext cx="3947008" cy="320040"/>
+          </a:xfrm>
+          <a:prstGeom prst="rect">
+            <a:avLst/>
+          </a:prstGeom>
+          <a:noFill/>
+          <a:ln/>
+        </p:spPr>
+        <p:txBody>
+          <a:bodyPr wrap="square" rtlCol="0" anchor="ctr"/>
+          <a:lstStyle/>
+          <a:p>
+            <a:pPr indent="0" marL="0">
+              <a:buNone/>
+            </a:pPr>
+            <a:r>
+              <a:rPr lang="en-US" sz="1250" b="1" spc="100" kern="0" dirty="0">
+                <a:solidFill>
+                  <a:srgbClr val="47602D"/>
+                </a:solidFill>
+                <a:latin typeface="Calibri" pitchFamily="34" charset="0"/>
+                <a:ea typeface="Calibri" pitchFamily="34" charset="-122"/>
+                <a:cs typeface="Calibri" pitchFamily="34" charset="-120"/>
+              </a:rPr>
+              <a:t>Lead time</a:t>
+            </a:r>
+            <a:endParaRPr lang="en-US" sz="1250" dirty="0"/>
+          </a:p>
+        </p:txBody>
+      </p:sp>
+      <p:sp>
+        <p:nvSpPr>
+          <p:cNvPr id="20" name="Text 18"/>
+          <p:cNvSpPr/>
+          <p:nvPr/>
+        </p:nvSpPr>
+        <p:spPr>
+          <a:xfrm>
+            <a:off x="1737360" y="3913632"/>
+            <a:ext cx="3901288" cy="594360"/>
+          </a:xfrm>
+          <a:prstGeom prst="rect">
+            <a:avLst/>
+          </a:prstGeom>
+          <a:noFill/>
+          <a:ln/>
+        </p:spPr>
+        <p:txBody>
+          <a:bodyPr wrap="square" rtlCol="0" anchor="t"/>
+          <a:lstStyle/>
+          <a:p>
+            <a:pPr indent="0" marL="0">
+              <a:buNone/>
+            </a:pPr>
+            <a:r>
+              <a:rPr lang="en-US" sz="1200" dirty="0">
+                <a:solidFill>
+                  <a:srgbClr val="2C332A"/>
+                </a:solidFill>
+                <a:latin typeface="Calibri" pitchFamily="34" charset="0"/>
+                <a:ea typeface="Calibri" pitchFamily="34" charset="-122"/>
+                <a:cs typeface="Calibri" pitchFamily="34" charset="-120"/>
+              </a:rPr>
+              <a:t>Finished SKUs: 10 days   ·   Bulk: 2–3 weeks (made to order)</a:t>
+            </a:r>
+            <a:endParaRPr lang="en-US" sz="1200" dirty="0"/>
+          </a:p>
+        </p:txBody>
+      </p:sp>
+      <p:sp>
+        <p:nvSpPr>
+          <p:cNvPr id="21" name="Shape 19"/>
+          <p:cNvSpPr/>
+          <p:nvPr/>
+        </p:nvSpPr>
+        <p:spPr>
+          <a:xfrm>
+            <a:off x="6324448" y="3364992"/>
+            <a:ext cx="5227168" cy="1188720"/>
+          </a:xfrm>
+          <a:prstGeom prst="roundRect">
+            <a:avLst>
+              <a:gd name="adj" fmla="val 6154"/>
+            </a:avLst>
+          </a:prstGeom>
+          <a:solidFill>
+            <a:srgbClr val="F6F4EC"/>
+          </a:solidFill>
+          <a:ln w="12700">
+            <a:solidFill>
+              <a:srgbClr val="E2DFD4"/>
+            </a:solidFill>
+            <a:prstDash val="solid"/>
+          </a:ln>
+        </p:spPr>
+      </p:sp>
+      <p:sp>
+        <p:nvSpPr>
+          <p:cNvPr id="22" name="Shape 20"/>
+          <p:cNvSpPr/>
+          <p:nvPr/>
+        </p:nvSpPr>
+        <p:spPr>
+          <a:xfrm>
+            <a:off x="6644488" y="3685032"/>
+            <a:ext cx="566928" cy="566928"/>
+          </a:xfrm>
+          <a:prstGeom prst="ellipse">
+            <a:avLst/>
+          </a:prstGeom>
+          <a:solidFill>
+            <a:srgbClr val="5E7A3C"/>
+          </a:solidFill>
+          <a:ln/>
+        </p:spPr>
+      </p:sp>
+      <p:sp>
+        <p:nvSpPr>
+          <p:cNvPr id="23" name="Text 21"/>
+          <p:cNvSpPr/>
+          <p:nvPr/>
+        </p:nvSpPr>
+        <p:spPr>
+          <a:xfrm>
+            <a:off x="6644488" y="3685032"/>
+            <a:ext cx="566928" cy="566928"/>
+          </a:xfrm>
+          <a:prstGeom prst="rect">
+            <a:avLst/>
+          </a:prstGeom>
+          <a:noFill/>
+          <a:ln/>
+        </p:spPr>
+        <p:txBody>
+          <a:bodyPr wrap="square" rtlCol="0" anchor="ctr"/>
+          <a:lstStyle/>
+          <a:p>
+            <a:pPr algn="ctr" indent="0" marL="0">
+              <a:buNone/>
+            </a:pPr>
+            <a:r>
+              <a:rPr lang="en-US" sz="2200" b="1" dirty="0">
+                <a:solidFill>
+                  <a:srgbClr val="FFFFFF"/>
+                </a:solidFill>
+                <a:latin typeface="Cambria" pitchFamily="34" charset="0"/>
+                <a:ea typeface="Cambria" pitchFamily="34" charset="-122"/>
+                <a:cs typeface="Cambria" pitchFamily="34" charset="-120"/>
+              </a:rPr>
+              <a:t>S</a:t>
+            </a:r>
+            <a:endParaRPr lang="en-US" sz="2200" dirty="0"/>
+          </a:p>
+        </p:txBody>
+      </p:sp>
+      <p:sp>
+        <p:nvSpPr>
+          <p:cNvPr id="24" name="Text 22"/>
+          <p:cNvSpPr/>
+          <p:nvPr/>
+        </p:nvSpPr>
+        <p:spPr>
+          <a:xfrm>
+            <a:off x="7421728" y="3584448"/>
+            <a:ext cx="3947008" cy="320040"/>
+          </a:xfrm>
+          <a:prstGeom prst="rect">
+            <a:avLst/>
+          </a:prstGeom>
+          <a:noFill/>
+          <a:ln/>
+        </p:spPr>
+        <p:txBody>
+          <a:bodyPr wrap="square" rtlCol="0" anchor="ctr"/>
+          <a:lstStyle/>
+          <a:p>
+            <a:pPr indent="0" marL="0">
+              <a:buNone/>
+            </a:pPr>
+            <a:r>
+              <a:rPr lang="en-US" sz="1250" b="1" spc="100" kern="0" dirty="0">
+                <a:solidFill>
+                  <a:srgbClr val="47602D"/>
+                </a:solidFill>
+                <a:latin typeface="Calibri" pitchFamily="34" charset="0"/>
+                <a:ea typeface="Calibri" pitchFamily="34" charset="-122"/>
+                <a:cs typeface="Calibri" pitchFamily="34" charset="-120"/>
+              </a:rPr>
+              <a:t>Shipping</a:t>
+            </a:r>
+            <a:endParaRPr lang="en-US" sz="1250" dirty="0"/>
+          </a:p>
+        </p:txBody>
+      </p:sp>
+      <p:sp>
+        <p:nvSpPr>
+          <p:cNvPr id="25" name="Text 23"/>
+          <p:cNvSpPr/>
+          <p:nvPr/>
+        </p:nvSpPr>
+        <p:spPr>
+          <a:xfrm>
+            <a:off x="7421728" y="3913632"/>
+            <a:ext cx="3901288" cy="594360"/>
+          </a:xfrm>
+          <a:prstGeom prst="rect">
+            <a:avLst/>
+          </a:prstGeom>
+          <a:noFill/>
+          <a:ln/>
+        </p:spPr>
+        <p:txBody>
+          <a:bodyPr wrap="square" rtlCol="0" anchor="t"/>
+          <a:lstStyle/>
+          <a:p>
+            <a:pPr indent="0" marL="0">
+              <a:buNone/>
+            </a:pPr>
+            <a:r>
+              <a:rPr lang="en-US" sz="1200" dirty="0">
+                <a:solidFill>
+                  <a:srgbClr val="2C332A"/>
+                </a:solidFill>
+                <a:latin typeface="Calibri" pitchFamily="34" charset="0"/>
+                <a:ea typeface="Calibri" pitchFamily="34" charset="-122"/>
+                <a:cs typeface="Calibri" pitchFamily="34" charset="-120"/>
+              </a:rPr>
+              <a:t>Finished (Singapore): DDP, free over S$800   ·   Bulk: FOB Japan</a:t>
+            </a:r>
+            <a:endParaRPr lang="en-US" sz="1200" dirty="0"/>
+          </a:p>
+        </p:txBody>
+      </p:sp>
+      <p:sp>
+        <p:nvSpPr>
+          <p:cNvPr id="26" name="Shape 24"/>
+          <p:cNvSpPr/>
+          <p:nvPr/>
+        </p:nvSpPr>
+        <p:spPr>
+          <a:xfrm>
+            <a:off x="640080" y="4809744"/>
+            <a:ext cx="5227168" cy="1188720"/>
+          </a:xfrm>
+          <a:prstGeom prst="roundRect">
+            <a:avLst>
+              <a:gd name="adj" fmla="val 6154"/>
+            </a:avLst>
+          </a:prstGeom>
+          <a:solidFill>
+            <a:srgbClr val="F6F4EC"/>
+          </a:solidFill>
+          <a:ln w="12700">
+            <a:solidFill>
+              <a:srgbClr val="E2DFD4"/>
+            </a:solidFill>
+            <a:prstDash val="solid"/>
+          </a:ln>
+        </p:spPr>
+      </p:sp>
+      <p:sp>
+        <p:nvSpPr>
+          <p:cNvPr id="27" name="Shape 25"/>
+          <p:cNvSpPr/>
+          <p:nvPr/>
+        </p:nvSpPr>
+        <p:spPr>
+          <a:xfrm>
+            <a:off x="960120" y="5129784"/>
+            <a:ext cx="566928" cy="566928"/>
+          </a:xfrm>
+          <a:prstGeom prst="ellipse">
+            <a:avLst/>
+          </a:prstGeom>
+          <a:solidFill>
+            <a:srgbClr val="5E7A3C"/>
+          </a:solidFill>
+          <a:ln/>
+        </p:spPr>
+      </p:sp>
+      <p:sp>
+        <p:nvSpPr>
+          <p:cNvPr id="28" name="Text 26"/>
+          <p:cNvSpPr/>
+          <p:nvPr/>
+        </p:nvSpPr>
+        <p:spPr>
+          <a:xfrm>
+            <a:off x="960120" y="5129784"/>
+            <a:ext cx="566928" cy="566928"/>
+          </a:xfrm>
+          <a:prstGeom prst="rect">
+            <a:avLst/>
+          </a:prstGeom>
+          <a:noFill/>
+          <a:ln/>
+        </p:spPr>
+        <p:txBody>
+          <a:bodyPr wrap="square" rtlCol="0" anchor="ctr"/>
+          <a:lstStyle/>
+          <a:p>
+            <a:pPr algn="ctr" indent="0" marL="0">
+              <a:buNone/>
+            </a:pPr>
+            <a:r>
+              <a:rPr lang="en-US" sz="2200" b="1" dirty="0">
+                <a:solidFill>
+                  <a:srgbClr val="FFFFFF"/>
+                </a:solidFill>
+                <a:latin typeface="Cambria" pitchFamily="34" charset="0"/>
+                <a:ea typeface="Cambria" pitchFamily="34" charset="-122"/>
+                <a:cs typeface="Cambria" pitchFamily="34" charset="-120"/>
+              </a:rPr>
+              <a:t>P</a:t>
+            </a:r>
+            <a:endParaRPr lang="en-US" sz="2200" dirty="0"/>
+          </a:p>
+        </p:txBody>
+      </p:sp>
+      <p:sp>
+        <p:nvSpPr>
+          <p:cNvPr id="29" name="Text 27"/>
+          <p:cNvSpPr/>
+          <p:nvPr/>
+        </p:nvSpPr>
+        <p:spPr>
+          <a:xfrm>
+            <a:off x="1737360" y="5029200"/>
+            <a:ext cx="3947008" cy="320040"/>
+          </a:xfrm>
+          <a:prstGeom prst="rect">
+            <a:avLst/>
+          </a:prstGeom>
+          <a:noFill/>
+          <a:ln/>
+        </p:spPr>
+        <p:txBody>
+          <a:bodyPr wrap="square" rtlCol="0" anchor="ctr"/>
+          <a:lstStyle/>
+          <a:p>
+            <a:pPr indent="0" marL="0">
+              <a:buNone/>
+            </a:pPr>
+            <a:r>
+              <a:rPr lang="en-US" sz="1250" b="1" spc="100" kern="0" dirty="0">
+                <a:solidFill>
+                  <a:srgbClr val="47602D"/>
+                </a:solidFill>
+                <a:latin typeface="Calibri" pitchFamily="34" charset="0"/>
+                <a:ea typeface="Calibri" pitchFamily="34" charset="-122"/>
+                <a:cs typeface="Calibri" pitchFamily="34" charset="-120"/>
+              </a:rPr>
+              <a:t>Payment</a:t>
+            </a:r>
+            <a:endParaRPr lang="en-US" sz="1250" dirty="0"/>
+          </a:p>
+        </p:txBody>
+      </p:sp>
+      <p:sp>
+        <p:nvSpPr>
+          <p:cNvPr id="30" name="Text 28"/>
+          <p:cNvSpPr/>
+          <p:nvPr/>
+        </p:nvSpPr>
+        <p:spPr>
+          <a:xfrm>
+            <a:off x="1737360" y="5358384"/>
+            <a:ext cx="3901288" cy="594360"/>
+          </a:xfrm>
+          <a:prstGeom prst="rect">
+            <a:avLst/>
+          </a:prstGeom>
+          <a:noFill/>
+          <a:ln/>
+        </p:spPr>
+        <p:txBody>
+          <a:bodyPr wrap="square" rtlCol="0" anchor="t"/>
+          <a:lstStyle/>
+          <a:p>
+            <a:pPr indent="0" marL="0">
+              <a:buNone/>
+            </a:pPr>
+            <a:r>
+              <a:rPr lang="en-US" sz="1200" dirty="0">
+                <a:solidFill>
+                  <a:srgbClr val="2C332A"/>
+                </a:solidFill>
+                <a:latin typeface="Calibri" pitchFamily="34" charset="0"/>
+                <a:ea typeface="Calibri" pitchFamily="34" charset="-122"/>
+                <a:cs typeface="Calibri" pitchFamily="34" charset="-120"/>
+              </a:rPr>
+              <a:t>Advance payment (T/T) — production begins on confirmation</a:t>
+            </a:r>
+            <a:endParaRPr lang="en-US" sz="1200" dirty="0"/>
+          </a:p>
+        </p:txBody>
+      </p:sp>
+      <p:sp>
+        <p:nvSpPr>
+          <p:cNvPr id="31" name="Shape 29"/>
+          <p:cNvSpPr/>
+          <p:nvPr/>
+        </p:nvSpPr>
+        <p:spPr>
+          <a:xfrm>
+            <a:off x="6324448" y="4809744"/>
+            <a:ext cx="5227168" cy="1188720"/>
+          </a:xfrm>
+          <a:prstGeom prst="roundRect">
+            <a:avLst>
+              <a:gd name="adj" fmla="val 6154"/>
+            </a:avLst>
+          </a:prstGeom>
+          <a:solidFill>
+            <a:srgbClr val="F6F4EC"/>
+          </a:solidFill>
+          <a:ln w="12700">
+            <a:solidFill>
+              <a:srgbClr val="E2DFD4"/>
+            </a:solidFill>
+            <a:prstDash val="solid"/>
+          </a:ln>
+        </p:spPr>
+      </p:sp>
+      <p:sp>
+        <p:nvSpPr>
+          <p:cNvPr id="32" name="Shape 30"/>
+          <p:cNvSpPr/>
+          <p:nvPr/>
+        </p:nvSpPr>
+        <p:spPr>
+          <a:xfrm>
+            <a:off x="6644488" y="5129784"/>
+            <a:ext cx="566928" cy="566928"/>
+          </a:xfrm>
+          <a:prstGeom prst="ellipse">
+            <a:avLst/>
+          </a:prstGeom>
+          <a:solidFill>
+            <a:srgbClr val="5E7A3C"/>
+          </a:solidFill>
+          <a:ln/>
+        </p:spPr>
+      </p:sp>
+      <p:sp>
+        <p:nvSpPr>
+          <p:cNvPr id="33" name="Text 31"/>
+          <p:cNvSpPr/>
+          <p:nvPr/>
+        </p:nvSpPr>
+        <p:spPr>
+          <a:xfrm>
+            <a:off x="6644488" y="5129784"/>
+            <a:ext cx="566928" cy="566928"/>
+          </a:xfrm>
+          <a:prstGeom prst="rect">
+            <a:avLst/>
+          </a:prstGeom>
+          <a:noFill/>
+          <a:ln/>
+        </p:spPr>
+        <p:txBody>
+          <a:bodyPr wrap="square" rtlCol="0" anchor="ctr"/>
+          <a:lstStyle/>
+          <a:p>
+            <a:pPr algn="ctr" indent="0" marL="0">
+              <a:buNone/>
+            </a:pPr>
+            <a:r>
+              <a:rPr lang="en-US" sz="2200" b="1" dirty="0">
+                <a:solidFill>
+                  <a:srgbClr val="FFFFFF"/>
+                </a:solidFill>
+                <a:latin typeface="Cambria" pitchFamily="34" charset="0"/>
+                <a:ea typeface="Cambria" pitchFamily="34" charset="-122"/>
+                <a:cs typeface="Cambria" pitchFamily="34" charset="-120"/>
+              </a:rPr>
+              <a:t>S</a:t>
+            </a:r>
+            <a:endParaRPr lang="en-US" sz="2200" dirty="0"/>
+          </a:p>
+        </p:txBody>
+      </p:sp>
+      <p:sp>
+        <p:nvSpPr>
+          <p:cNvPr id="34" name="Text 32"/>
+          <p:cNvSpPr/>
+          <p:nvPr/>
+        </p:nvSpPr>
+        <p:spPr>
+          <a:xfrm>
+            <a:off x="7421728" y="5029200"/>
+            <a:ext cx="3947008" cy="320040"/>
+          </a:xfrm>
+          <a:prstGeom prst="rect">
+            <a:avLst/>
+          </a:prstGeom>
+          <a:noFill/>
+          <a:ln/>
+        </p:spPr>
+        <p:txBody>
+          <a:bodyPr wrap="square" rtlCol="0" anchor="ctr"/>
+          <a:lstStyle/>
+          <a:p>
+            <a:pPr indent="0" marL="0">
+              <a:buNone/>
+            </a:pPr>
+            <a:r>
+              <a:rPr lang="en-US" sz="1250" b="1" spc="100" kern="0" dirty="0">
+                <a:solidFill>
+                  <a:srgbClr val="47602D"/>
+                </a:solidFill>
+                <a:latin typeface="Calibri" pitchFamily="34" charset="0"/>
+                <a:ea typeface="Calibri" pitchFamily="34" charset="-122"/>
+                <a:cs typeface="Calibri" pitchFamily="34" charset="-120"/>
+              </a:rPr>
+              <a:t>Samples</a:t>
+            </a:r>
+            <a:endParaRPr lang="en-US" sz="1250" dirty="0"/>
+          </a:p>
+        </p:txBody>
+      </p:sp>
+      <p:sp>
+        <p:nvSpPr>
+          <p:cNvPr id="35" name="Text 33"/>
+          <p:cNvSpPr/>
+          <p:nvPr/>
+        </p:nvSpPr>
+        <p:spPr>
+          <a:xfrm>
+            <a:off x="7421728" y="5358384"/>
+            <a:ext cx="3901288" cy="594360"/>
+          </a:xfrm>
+          <a:prstGeom prst="rect">
+            <a:avLst/>
+          </a:prstGeom>
+          <a:noFill/>
+          <a:ln/>
+        </p:spPr>
+        <p:txBody>
+          <a:bodyPr wrap="square" rtlCol="0" anchor="t"/>
+          <a:lstStyle/>
+          <a:p>
+            <a:pPr indent="0" marL="0">
+              <a:buNone/>
+            </a:pPr>
+            <a:r>
+              <a:rPr lang="en-US" sz="1200" dirty="0">
+                <a:solidFill>
+                  <a:srgbClr val="2C332A"/>
+                </a:solidFill>
+                <a:latin typeface="Calibri" pitchFamily="34" charset="0"/>
+                <a:ea typeface="Calibri" pitchFamily="34" charset="-122"/>
+                <a:cs typeface="Calibri" pitchFamily="34" charset="-120"/>
+              </a:rPr>
+              <a:t>Complimentary for qualified buyers</a:t>
+            </a:r>
+            <a:endParaRPr lang="en-US" sz="1200" dirty="0"/>
+          </a:p>
+        </p:txBody>
+      </p:sp>
+      <p:sp>
+        <p:nvSpPr>
+          <p:cNvPr id="36" name="Text 34"/>
+          <p:cNvSpPr/>
+          <p:nvPr/>
+        </p:nvSpPr>
+        <p:spPr>
+          <a:xfrm>
+            <a:off x="640080" y="6053328"/>
+            <a:ext cx="10515600" cy="274320"/>
+          </a:xfrm>
+          <a:prstGeom prst="rect">
+            <a:avLst/>
+          </a:prstGeom>
+          <a:noFill/>
+          <a:ln/>
+        </p:spPr>
+        <p:txBody>
+          <a:bodyPr wrap="square" rtlCol="0" anchor="ctr"/>
+          <a:lstStyle/>
+          <a:p>
+            <a:pPr indent="0" marL="0">
+              <a:buNone/>
+            </a:pPr>
+            <a:r>
+              <a:rPr lang="en-US" sz="1050" i="1" dirty="0">
+                <a:solidFill>
+                  <a:srgbClr val="70776B"/>
+                </a:solidFill>
+                <a:latin typeface="Calibri" pitchFamily="34" charset="0"/>
+                <a:ea typeface="Calibri" pitchFamily="34" charset="-122"/>
+                <a:cs typeface="Calibri" pitchFamily="34" charset="-120"/>
+              </a:rPr>
+              <a:t>All prices in SGD, subject to FX.</a:t>
+            </a:r>
+            <a:endParaRPr lang="en-US" sz="1050" dirty="0"/>
+          </a:p>
+        </p:txBody>
+      </p:sp>
+      <p:sp>
+        <p:nvSpPr>
+          <p:cNvPr id="37" name="Text 35"/>
+          <p:cNvSpPr/>
+          <p:nvPr/>
+        </p:nvSpPr>
+        <p:spPr>
+          <a:xfrm>
+            <a:off x="640080" y="6400800"/>
+            <a:ext cx="5486400" cy="274320"/>
+          </a:xfrm>
+          <a:prstGeom prst="rect">
+            <a:avLst/>
+          </a:prstGeom>
+          <a:noFill/>
+          <a:ln/>
+        </p:spPr>
+        <p:txBody>
+          <a:bodyPr wrap="square" rtlCol="0" anchor="ctr"/>
+          <a:lstStyle/>
+          <a:p>
+            <a:pPr algn="l" indent="0" marL="0">
+              <a:buNone/>
+            </a:pPr>
+            <a:r>
+              <a:rPr lang="en-US" sz="900" dirty="0">
+                <a:solidFill>
+                  <a:srgbClr val="70776B"/>
+                </a:solidFill>
+                <a:latin typeface="Calibri" pitchFamily="34" charset="0"/>
+                <a:ea typeface="Calibri" pitchFamily="34" charset="-122"/>
+                <a:cs typeface="Calibri" pitchFamily="34" charset="-120"/>
+              </a:rPr>
+              <a:t>SHIZUNE MATCHA  ·  Traverse Asia</a:t>
+            </a:r>
+            <a:endParaRPr lang="en-US" sz="900" dirty="0"/>
+          </a:p>
+        </p:txBody>
+      </p:sp>
+      <p:sp>
+        <p:nvSpPr>
+          <p:cNvPr id="38" name="Text 36"/>
+          <p:cNvSpPr/>
+          <p:nvPr/>
+        </p:nvSpPr>
+        <p:spPr>
+          <a:xfrm>
+            <a:off x="8808415" y="6400800"/>
+            <a:ext cx="2743200" cy="274320"/>
+          </a:xfrm>
+          <a:prstGeom prst="rect">
+            <a:avLst/>
+          </a:prstGeom>
+          <a:noFill/>
+          <a:ln/>
+        </p:spPr>
+        <p:txBody>
+          <a:bodyPr wrap="square" rtlCol="0" anchor="ctr"/>
+          <a:lstStyle/>
+          <a:p>
+            <a:pPr algn="r" indent="0" marL="0">
+              <a:buNone/>
+            </a:pPr>
+            <a:r>
+              <a:rPr lang="en-US" sz="900" dirty="0">
+                <a:solidFill>
+                  <a:srgbClr val="70776B"/>
+                </a:solidFill>
+                <a:latin typeface="Calibri" pitchFamily="34" charset="0"/>
+                <a:ea typeface="Calibri" pitchFamily="34" charset="-122"/>
+                <a:cs typeface="Calibri" pitchFamily="34" charset="-120"/>
+              </a:rPr>
+              <a:t>shizunematcha.com</a:t>
+            </a:r>
+            <a:endParaRPr lang="en-US" sz="900" dirty="0"/>
+          </a:p>
+        </p:txBody>
+      </p:sp>
+    </p:spTree>
+  </p:cSld>
+  <p:clrMapOvr>
+    <a:masterClrMapping/>
+  </p:clrMapOvr>
+</p:sld>
+</file>
+
+<file path=ppt/slides/slide11.xml><?xml version="1.0" encoding="utf-8"?>
+<p:sld xmlns:a="http://schemas.openxmlformats.org/drawingml/2006/main" xmlns:r="http://schemas.openxmlformats.org/officeDocument/2006/relationships" xmlns:p="http://schemas.openxmlformats.org/presentationml/2006/main">
+  <p:cSld name="Slide 11">
+    <p:bg>
+      <p:bgPr>
+        <a:solidFill>
           <a:srgbClr val="F6F4EC"/>
         </a:solidFill>
       </p:bgPr>
@@ -2268,7 +3627,7 @@
                 <a:ea typeface="Calibri" pitchFamily="34" charset="-122"/>
                 <a:cs typeface="Calibri" pitchFamily="34" charset="-120"/>
               </a:rPr>
-              <a:t>10</a:t>
+              <a:t>11</a:t>
             </a:r>
             <a:endParaRPr lang="en-US" sz="1000" dirty="0"/>
           </a:p>
@@ -2776,9 +4135,9 @@
 </p:sld>
 </file>
 
-<file path=ppt/slides/slide11.xml><?xml version="1.0" encoding="utf-8"?>
+<file path=ppt/slides/slide12.xml><?xml version="1.0" encoding="utf-8"?>
 <p:sld xmlns:a="http://schemas.openxmlformats.org/drawingml/2006/main" xmlns:r="http://schemas.openxmlformats.org/officeDocument/2006/relationships" xmlns:p="http://schemas.openxmlformats.org/presentationml/2006/main">
-  <p:cSld name="Slide 11">
+  <p:cSld name="Slide 12">
     <p:bg>
       <p:bgPr>
         <a:solidFill>
@@ -2892,7 +4251,7 @@
                 <a:ea typeface="Calibri" pitchFamily="34" charset="-122"/>
                 <a:cs typeface="Calibri" pitchFamily="34" charset="-120"/>
               </a:rPr>
-              <a:t>11</a:t>
+              <a:t>12</a:t>
             </a:r>
             <a:endParaRPr lang="en-US" sz="1000" dirty="0"/>
           </a:p>
@@ -3796,9 +5155,9 @@
 </p:sld>
 </file>
 
-<file path=ppt/slides/slide12.xml><?xml version="1.0" encoding="utf-8"?>
+<file path=ppt/slides/slide13.xml><?xml version="1.0" encoding="utf-8"?>
 <p:sld xmlns:a="http://schemas.openxmlformats.org/drawingml/2006/main" xmlns:r="http://schemas.openxmlformats.org/officeDocument/2006/relationships" xmlns:p="http://schemas.openxmlformats.org/presentationml/2006/main">
-  <p:cSld name="Slide 12">
+  <p:cSld name="Slide 13">
     <p:bg>
       <p:bgPr>
         <a:solidFill>
@@ -5688,6 +7047,1031 @@
     <p:bg>
       <p:bgPr>
         <a:solidFill>
+          <a:srgbClr val="FFFFFF"/>
+        </a:solidFill>
+      </p:bgPr>
+    </p:bg>
+    <p:spTree>
+      <p:nvGrpSpPr>
+        <p:cNvPr id="1" name=""/>
+        <p:cNvGrpSpPr/>
+        <p:nvPr/>
+      </p:nvGrpSpPr>
+      <p:grpSpPr>
+        <a:xfrm>
+          <a:off x="0" y="0"/>
+          <a:ext cx="0" cy="0"/>
+          <a:chOff x="0" y="0"/>
+          <a:chExt cx="0" cy="0"/>
+        </a:xfrm>
+      </p:grpSpPr>
+      <p:sp>
+        <p:nvSpPr>
+          <p:cNvPr id="2" name="Shape 0"/>
+          <p:cNvSpPr/>
+          <p:nvPr/>
+        </p:nvSpPr>
+        <p:spPr>
+          <a:xfrm>
+            <a:off x="640080" y="667512"/>
+            <a:ext cx="109728" cy="109728"/>
+          </a:xfrm>
+          <a:prstGeom prst="ellipse">
+            <a:avLst/>
+          </a:prstGeom>
+          <a:solidFill>
+            <a:srgbClr val="5E7A3C"/>
+          </a:solidFill>
+          <a:ln/>
+        </p:spPr>
+      </p:sp>
+      <p:sp>
+        <p:nvSpPr>
+          <p:cNvPr id="3" name="Text 1"/>
+          <p:cNvSpPr/>
+          <p:nvPr/>
+        </p:nvSpPr>
+        <p:spPr>
+          <a:xfrm>
+            <a:off x="841248" y="603504"/>
+            <a:ext cx="5486400" cy="256032"/>
+          </a:xfrm>
+          <a:prstGeom prst="rect">
+            <a:avLst/>
+          </a:prstGeom>
+          <a:noFill/>
+          <a:ln/>
+        </p:spPr>
+        <p:txBody>
+          <a:bodyPr wrap="square" rtlCol="0" anchor="ctr"/>
+          <a:lstStyle/>
+          <a:p>
+            <a:pPr algn="l" indent="0" marL="0">
+              <a:buNone/>
+            </a:pPr>
+            <a:r>
+              <a:rPr lang="en-US" sz="1100" b="1" spc="200" kern="0" dirty="0">
+                <a:solidFill>
+                  <a:srgbClr val="5E7A3C"/>
+                </a:solidFill>
+                <a:latin typeface="Calibri" pitchFamily="34" charset="0"/>
+                <a:ea typeface="Calibri" pitchFamily="34" charset="-122"/>
+                <a:cs typeface="Calibri" pitchFamily="34" charset="-120"/>
+              </a:rPr>
+              <a:t>THE REGION</a:t>
+            </a:r>
+            <a:endParaRPr lang="en-US" sz="1100" dirty="0"/>
+          </a:p>
+        </p:txBody>
+      </p:sp>
+      <p:sp>
+        <p:nvSpPr>
+          <p:cNvPr id="4" name="Text 2"/>
+          <p:cNvSpPr/>
+          <p:nvPr/>
+        </p:nvSpPr>
+        <p:spPr>
+          <a:xfrm>
+            <a:off x="10820095" y="502920"/>
+            <a:ext cx="731520" cy="274320"/>
+          </a:xfrm>
+          <a:prstGeom prst="rect">
+            <a:avLst/>
+          </a:prstGeom>
+          <a:noFill/>
+          <a:ln/>
+        </p:spPr>
+        <p:txBody>
+          <a:bodyPr wrap="square" rtlCol="0" anchor="ctr"/>
+          <a:lstStyle/>
+          <a:p>
+            <a:pPr algn="r" indent="0" marL="0">
+              <a:buNone/>
+            </a:pPr>
+            <a:r>
+              <a:rPr lang="en-US" sz="1000" b="1" dirty="0">
+                <a:solidFill>
+                  <a:srgbClr val="9DAE86"/>
+                </a:solidFill>
+                <a:latin typeface="Calibri" pitchFamily="34" charset="0"/>
+                <a:ea typeface="Calibri" pitchFamily="34" charset="-122"/>
+                <a:cs typeface="Calibri" pitchFamily="34" charset="-120"/>
+              </a:rPr>
+              <a:t>04</a:t>
+            </a:r>
+            <a:endParaRPr lang="en-US" sz="1000" dirty="0"/>
+          </a:p>
+        </p:txBody>
+      </p:sp>
+      <p:sp>
+        <p:nvSpPr>
+          <p:cNvPr id="5" name="Text 3"/>
+          <p:cNvSpPr/>
+          <p:nvPr/>
+        </p:nvSpPr>
+        <p:spPr>
+          <a:xfrm>
+            <a:off x="640080" y="1051560"/>
+            <a:ext cx="10515600" cy="640080"/>
+          </a:xfrm>
+          <a:prstGeom prst="rect">
+            <a:avLst/>
+          </a:prstGeom>
+          <a:noFill/>
+          <a:ln/>
+        </p:spPr>
+        <p:txBody>
+          <a:bodyPr wrap="square" rtlCol="0" anchor="ctr"/>
+          <a:lstStyle/>
+          <a:p>
+            <a:pPr indent="0" marL="0">
+              <a:buNone/>
+            </a:pPr>
+            <a:r>
+              <a:rPr lang="en-US" sz="3400" dirty="0">
+                <a:solidFill>
+                  <a:srgbClr val="2C332A"/>
+                </a:solidFill>
+                <a:latin typeface="Cambria" pitchFamily="34" charset="0"/>
+                <a:ea typeface="Cambria" pitchFamily="34" charset="-122"/>
+                <a:cs typeface="Cambria" pitchFamily="34" charset="-120"/>
+              </a:rPr>
+              <a:t>Where is Shizuoka?</a:t>
+            </a:r>
+            <a:endParaRPr lang="en-US" sz="3400" dirty="0"/>
+          </a:p>
+        </p:txBody>
+      </p:sp>
+      <p:sp>
+        <p:nvSpPr>
+          <p:cNvPr id="6" name="Text 4"/>
+          <p:cNvSpPr/>
+          <p:nvPr/>
+        </p:nvSpPr>
+        <p:spPr>
+          <a:xfrm>
+            <a:off x="640080" y="1783080"/>
+            <a:ext cx="10515600" cy="365760"/>
+          </a:xfrm>
+          <a:prstGeom prst="rect">
+            <a:avLst/>
+          </a:prstGeom>
+          <a:noFill/>
+          <a:ln/>
+        </p:spPr>
+        <p:txBody>
+          <a:bodyPr wrap="square" rtlCol="0" anchor="ctr"/>
+          <a:lstStyle/>
+          <a:p>
+            <a:pPr indent="0" marL="0">
+              <a:buNone/>
+            </a:pPr>
+            <a:r>
+              <a:rPr lang="en-US" sz="1450" dirty="0">
+                <a:solidFill>
+                  <a:srgbClr val="70776B"/>
+                </a:solidFill>
+                <a:latin typeface="Calibri" pitchFamily="34" charset="0"/>
+                <a:ea typeface="Calibri" pitchFamily="34" charset="-122"/>
+                <a:cs typeface="Calibri" pitchFamily="34" charset="-120"/>
+              </a:rPr>
+              <a:t>Japan’s most celebrated tea region — at the foot of Mt. Fuji.</a:t>
+            </a:r>
+            <a:endParaRPr lang="en-US" sz="1450" dirty="0"/>
+          </a:p>
+        </p:txBody>
+      </p:sp>
+      <p:sp>
+        <p:nvSpPr>
+          <p:cNvPr id="7" name="Shape 5"/>
+          <p:cNvSpPr/>
+          <p:nvPr/>
+        </p:nvSpPr>
+        <p:spPr>
+          <a:xfrm>
+            <a:off x="640080" y="2331720"/>
+            <a:ext cx="5212080" cy="3611880"/>
+          </a:xfrm>
+          <a:prstGeom prst="roundRect">
+            <a:avLst>
+              <a:gd name="adj" fmla="val 2025"/>
+            </a:avLst>
+          </a:prstGeom>
+          <a:solidFill>
+            <a:srgbClr val="F6F4EC"/>
+          </a:solidFill>
+          <a:ln w="12700">
+            <a:solidFill>
+              <a:srgbClr val="E2DFD4"/>
+            </a:solidFill>
+            <a:prstDash val="solid"/>
+          </a:ln>
+        </p:spPr>
+      </p:sp>
+      <p:sp>
+        <p:nvSpPr>
+          <p:cNvPr id="8" name="Text 6"/>
+          <p:cNvSpPr/>
+          <p:nvPr/>
+        </p:nvSpPr>
+        <p:spPr>
+          <a:xfrm>
+            <a:off x="960120" y="2560320"/>
+            <a:ext cx="1828800" cy="274320"/>
+          </a:xfrm>
+          <a:prstGeom prst="rect">
+            <a:avLst/>
+          </a:prstGeom>
+          <a:noFill/>
+          <a:ln/>
+        </p:spPr>
+        <p:txBody>
+          <a:bodyPr wrap="square" rtlCol="0" anchor="ctr"/>
+          <a:lstStyle/>
+          <a:p>
+            <a:pPr indent="0" marL="0">
+              <a:buNone/>
+            </a:pPr>
+            <a:r>
+              <a:rPr lang="en-US" sz="1100" b="1" spc="300" kern="0" dirty="0">
+                <a:solidFill>
+                  <a:srgbClr val="9DAE86"/>
+                </a:solidFill>
+                <a:latin typeface="Calibri" pitchFamily="34" charset="0"/>
+                <a:ea typeface="Calibri" pitchFamily="34" charset="-122"/>
+                <a:cs typeface="Calibri" pitchFamily="34" charset="-120"/>
+              </a:rPr>
+              <a:t>JAPAN</a:t>
+            </a:r>
+            <a:endParaRPr lang="en-US" sz="1100" dirty="0"/>
+          </a:p>
+        </p:txBody>
+      </p:sp>
+      <p:sp>
+        <p:nvSpPr>
+          <p:cNvPr id="9" name="Shape 7"/>
+          <p:cNvSpPr/>
+          <p:nvPr/>
+        </p:nvSpPr>
+        <p:spPr>
+          <a:xfrm>
+            <a:off x="2240280" y="3108960"/>
+            <a:ext cx="1737360" cy="1234440"/>
+          </a:xfrm>
+          <a:prstGeom prst="triangle">
+            <a:avLst/>
+          </a:prstGeom>
+          <a:solidFill>
+            <a:srgbClr val="9DAE86"/>
+          </a:solidFill>
+          <a:ln/>
+        </p:spPr>
+      </p:sp>
+      <p:sp>
+        <p:nvSpPr>
+          <p:cNvPr id="10" name="Shape 8"/>
+          <p:cNvSpPr/>
+          <p:nvPr/>
+        </p:nvSpPr>
+        <p:spPr>
+          <a:xfrm>
+            <a:off x="2852928" y="3108960"/>
+            <a:ext cx="512064" cy="384048"/>
+          </a:xfrm>
+          <a:prstGeom prst="triangle">
+            <a:avLst/>
+          </a:prstGeom>
+          <a:solidFill>
+            <a:srgbClr val="FFFFFF"/>
+          </a:solidFill>
+          <a:ln/>
+        </p:spPr>
+      </p:sp>
+      <p:sp>
+        <p:nvSpPr>
+          <p:cNvPr id="11" name="Shape 9"/>
+          <p:cNvSpPr/>
+          <p:nvPr/>
+        </p:nvSpPr>
+        <p:spPr>
+          <a:xfrm>
+            <a:off x="2953512" y="4462272"/>
+            <a:ext cx="713232" cy="713232"/>
+          </a:xfrm>
+          <a:prstGeom prst="ellipse">
+            <a:avLst/>
+          </a:prstGeom>
+          <a:solidFill>
+            <a:srgbClr val="F6F4EC"/>
+          </a:solidFill>
+          <a:ln w="19050">
+            <a:solidFill>
+              <a:srgbClr val="5E7A3C"/>
+            </a:solidFill>
+            <a:prstDash val="solid"/>
+          </a:ln>
+        </p:spPr>
+      </p:sp>
+      <p:sp>
+        <p:nvSpPr>
+          <p:cNvPr id="12" name="Shape 10"/>
+          <p:cNvSpPr/>
+          <p:nvPr/>
+        </p:nvSpPr>
+        <p:spPr>
+          <a:xfrm>
+            <a:off x="3182112" y="4690872"/>
+            <a:ext cx="292608" cy="292608"/>
+          </a:xfrm>
+          <a:prstGeom prst="ellipse">
+            <a:avLst/>
+          </a:prstGeom>
+          <a:solidFill>
+            <a:srgbClr val="5E7A3C"/>
+          </a:solidFill>
+          <a:ln/>
+        </p:spPr>
+      </p:sp>
+      <p:sp>
+        <p:nvSpPr>
+          <p:cNvPr id="13" name="Text 11"/>
+          <p:cNvSpPr/>
+          <p:nvPr/>
+        </p:nvSpPr>
+        <p:spPr>
+          <a:xfrm>
+            <a:off x="3794760" y="4526280"/>
+            <a:ext cx="2103120" cy="365760"/>
+          </a:xfrm>
+          <a:prstGeom prst="rect">
+            <a:avLst/>
+          </a:prstGeom>
+          <a:noFill/>
+          <a:ln/>
+        </p:spPr>
+        <p:txBody>
+          <a:bodyPr wrap="square" rtlCol="0" anchor="ctr"/>
+          <a:lstStyle/>
+          <a:p>
+            <a:pPr indent="0" marL="0">
+              <a:buNone/>
+            </a:pPr>
+            <a:r>
+              <a:rPr lang="en-US" sz="1400" b="1" dirty="0">
+                <a:solidFill>
+                  <a:srgbClr val="47602D"/>
+                </a:solidFill>
+                <a:latin typeface="Calibri" pitchFamily="34" charset="0"/>
+                <a:ea typeface="Calibri" pitchFamily="34" charset="-122"/>
+                <a:cs typeface="Calibri" pitchFamily="34" charset="-120"/>
+              </a:rPr>
+              <a:t>Shizuoka</a:t>
+            </a:r>
+            <a:endParaRPr lang="en-US" sz="1400" dirty="0"/>
+          </a:p>
+        </p:txBody>
+      </p:sp>
+      <p:sp>
+        <p:nvSpPr>
+          <p:cNvPr id="14" name="Shape 12"/>
+          <p:cNvSpPr/>
+          <p:nvPr/>
+        </p:nvSpPr>
+        <p:spPr>
+          <a:xfrm>
+            <a:off x="4800600" y="3566160"/>
+            <a:ext cx="146304" cy="146304"/>
+          </a:xfrm>
+          <a:prstGeom prst="ellipse">
+            <a:avLst/>
+          </a:prstGeom>
+          <a:solidFill>
+            <a:srgbClr val="70776B"/>
+          </a:solidFill>
+          <a:ln/>
+        </p:spPr>
+      </p:sp>
+      <p:sp>
+        <p:nvSpPr>
+          <p:cNvPr id="15" name="Text 13"/>
+          <p:cNvSpPr/>
+          <p:nvPr/>
+        </p:nvSpPr>
+        <p:spPr>
+          <a:xfrm>
+            <a:off x="4343400" y="3291840"/>
+            <a:ext cx="1188720" cy="256032"/>
+          </a:xfrm>
+          <a:prstGeom prst="rect">
+            <a:avLst/>
+          </a:prstGeom>
+          <a:noFill/>
+          <a:ln/>
+        </p:spPr>
+        <p:txBody>
+          <a:bodyPr wrap="square" rtlCol="0" anchor="ctr"/>
+          <a:lstStyle/>
+          <a:p>
+            <a:pPr algn="ctr" indent="0" marL="0">
+              <a:buNone/>
+            </a:pPr>
+            <a:r>
+              <a:rPr lang="en-US" sz="1050" dirty="0">
+                <a:solidFill>
+                  <a:srgbClr val="70776B"/>
+                </a:solidFill>
+                <a:latin typeface="Calibri" pitchFamily="34" charset="0"/>
+                <a:ea typeface="Calibri" pitchFamily="34" charset="-122"/>
+                <a:cs typeface="Calibri" pitchFamily="34" charset="-120"/>
+              </a:rPr>
+              <a:t>Tokyo</a:t>
+            </a:r>
+            <a:endParaRPr lang="en-US" sz="1050" dirty="0"/>
+          </a:p>
+        </p:txBody>
+      </p:sp>
+      <p:sp>
+        <p:nvSpPr>
+          <p:cNvPr id="16" name="Shape 14"/>
+          <p:cNvSpPr/>
+          <p:nvPr/>
+        </p:nvSpPr>
+        <p:spPr>
+          <a:xfrm>
+            <a:off x="1417320" y="4846320"/>
+            <a:ext cx="146304" cy="146304"/>
+          </a:xfrm>
+          <a:prstGeom prst="ellipse">
+            <a:avLst/>
+          </a:prstGeom>
+          <a:solidFill>
+            <a:srgbClr val="70776B"/>
+          </a:solidFill>
+          <a:ln/>
+        </p:spPr>
+      </p:sp>
+      <p:sp>
+        <p:nvSpPr>
+          <p:cNvPr id="17" name="Text 15"/>
+          <p:cNvSpPr/>
+          <p:nvPr/>
+        </p:nvSpPr>
+        <p:spPr>
+          <a:xfrm>
+            <a:off x="960120" y="4572000"/>
+            <a:ext cx="1188720" cy="256032"/>
+          </a:xfrm>
+          <a:prstGeom prst="rect">
+            <a:avLst/>
+          </a:prstGeom>
+          <a:noFill/>
+          <a:ln/>
+        </p:spPr>
+        <p:txBody>
+          <a:bodyPr wrap="square" rtlCol="0" anchor="ctr"/>
+          <a:lstStyle/>
+          <a:p>
+            <a:pPr algn="ctr" indent="0" marL="0">
+              <a:buNone/>
+            </a:pPr>
+            <a:r>
+              <a:rPr lang="en-US" sz="1050" dirty="0">
+                <a:solidFill>
+                  <a:srgbClr val="70776B"/>
+                </a:solidFill>
+                <a:latin typeface="Calibri" pitchFamily="34" charset="0"/>
+                <a:ea typeface="Calibri" pitchFamily="34" charset="-122"/>
+                <a:cs typeface="Calibri" pitchFamily="34" charset="-120"/>
+              </a:rPr>
+              <a:t>Kyoto</a:t>
+            </a:r>
+            <a:endParaRPr lang="en-US" sz="1050" dirty="0"/>
+          </a:p>
+        </p:txBody>
+      </p:sp>
+      <p:sp>
+        <p:nvSpPr>
+          <p:cNvPr id="18" name="Text 16"/>
+          <p:cNvSpPr/>
+          <p:nvPr/>
+        </p:nvSpPr>
+        <p:spPr>
+          <a:xfrm>
+            <a:off x="960120" y="5486400"/>
+            <a:ext cx="4572000" cy="274320"/>
+          </a:xfrm>
+          <a:prstGeom prst="rect">
+            <a:avLst/>
+          </a:prstGeom>
+          <a:noFill/>
+          <a:ln/>
+        </p:spPr>
+        <p:txBody>
+          <a:bodyPr wrap="square" rtlCol="0" anchor="ctr"/>
+          <a:lstStyle/>
+          <a:p>
+            <a:pPr indent="0" marL="0">
+              <a:buNone/>
+            </a:pPr>
+            <a:r>
+              <a:rPr lang="en-US" sz="1100" i="1" dirty="0">
+                <a:solidFill>
+                  <a:srgbClr val="70776B"/>
+                </a:solidFill>
+                <a:latin typeface="Calibri" pitchFamily="34" charset="0"/>
+                <a:ea typeface="Calibri" pitchFamily="34" charset="-122"/>
+                <a:cs typeface="Calibri" pitchFamily="34" charset="-120"/>
+              </a:rPr>
+              <a:t>Pacific coast  ·  Central Japan</a:t>
+            </a:r>
+            <a:endParaRPr lang="en-US" sz="1100" dirty="0"/>
+          </a:p>
+        </p:txBody>
+      </p:sp>
+      <p:sp>
+        <p:nvSpPr>
+          <p:cNvPr id="19" name="Shape 17"/>
+          <p:cNvSpPr/>
+          <p:nvPr/>
+        </p:nvSpPr>
+        <p:spPr>
+          <a:xfrm>
+            <a:off x="6446520" y="2368296"/>
+            <a:ext cx="402336" cy="402336"/>
+          </a:xfrm>
+          <a:prstGeom prst="ellipse">
+            <a:avLst/>
+          </a:prstGeom>
+          <a:solidFill>
+            <a:srgbClr val="5E7A3C"/>
+          </a:solidFill>
+          <a:ln/>
+        </p:spPr>
+      </p:sp>
+      <p:sp>
+        <p:nvSpPr>
+          <p:cNvPr id="20" name="Text 18"/>
+          <p:cNvSpPr/>
+          <p:nvPr/>
+        </p:nvSpPr>
+        <p:spPr>
+          <a:xfrm>
+            <a:off x="7040880" y="2286000"/>
+            <a:ext cx="4510735" cy="320040"/>
+          </a:xfrm>
+          <a:prstGeom prst="rect">
+            <a:avLst/>
+          </a:prstGeom>
+          <a:noFill/>
+          <a:ln/>
+        </p:spPr>
+        <p:txBody>
+          <a:bodyPr wrap="square" rtlCol="0" anchor="ctr"/>
+          <a:lstStyle/>
+          <a:p>
+            <a:pPr indent="0" marL="0">
+              <a:buNone/>
+            </a:pPr>
+            <a:r>
+              <a:rPr lang="en-US" sz="1600" dirty="0">
+                <a:solidFill>
+                  <a:srgbClr val="2C332A"/>
+                </a:solidFill>
+                <a:latin typeface="Cambria" pitchFamily="34" charset="0"/>
+                <a:ea typeface="Cambria" pitchFamily="34" charset="-122"/>
+                <a:cs typeface="Cambria" pitchFamily="34" charset="-120"/>
+              </a:rPr>
+              <a:t>Central Japan, Pacific coast</a:t>
+            </a:r>
+            <a:endParaRPr lang="en-US" sz="1600" dirty="0"/>
+          </a:p>
+        </p:txBody>
+      </p:sp>
+      <p:sp>
+        <p:nvSpPr>
+          <p:cNvPr id="21" name="Text 19"/>
+          <p:cNvSpPr/>
+          <p:nvPr/>
+        </p:nvSpPr>
+        <p:spPr>
+          <a:xfrm>
+            <a:off x="7040880" y="2642616"/>
+            <a:ext cx="4465015" cy="594360"/>
+          </a:xfrm>
+          <a:prstGeom prst="rect">
+            <a:avLst/>
+          </a:prstGeom>
+          <a:noFill/>
+          <a:ln/>
+        </p:spPr>
+        <p:txBody>
+          <a:bodyPr wrap="square" rtlCol="0" anchor="t"/>
+          <a:lstStyle/>
+          <a:p>
+            <a:pPr indent="0" marL="0">
+              <a:buNone/>
+            </a:pPr>
+            <a:r>
+              <a:rPr lang="en-US" sz="1250" dirty="0">
+                <a:solidFill>
+                  <a:srgbClr val="70776B"/>
+                </a:solidFill>
+                <a:latin typeface="Calibri" pitchFamily="34" charset="0"/>
+                <a:ea typeface="Calibri" pitchFamily="34" charset="-122"/>
+                <a:cs typeface="Calibri" pitchFamily="34" charset="-120"/>
+              </a:rPr>
+              <a:t>Between Tokyo and Kyoto, at the foot of Mt. Fuji — about 1.5 hours from Tokyo.</a:t>
+            </a:r>
+            <a:endParaRPr lang="en-US" sz="1250" dirty="0"/>
+          </a:p>
+        </p:txBody>
+      </p:sp>
+      <p:sp>
+        <p:nvSpPr>
+          <p:cNvPr id="22" name="Shape 20"/>
+          <p:cNvSpPr/>
+          <p:nvPr/>
+        </p:nvSpPr>
+        <p:spPr>
+          <a:xfrm>
+            <a:off x="6446520" y="3282696"/>
+            <a:ext cx="402336" cy="402336"/>
+          </a:xfrm>
+          <a:prstGeom prst="ellipse">
+            <a:avLst/>
+          </a:prstGeom>
+          <a:solidFill>
+            <a:srgbClr val="5E7A3C"/>
+          </a:solidFill>
+          <a:ln/>
+        </p:spPr>
+      </p:sp>
+      <p:sp>
+        <p:nvSpPr>
+          <p:cNvPr id="23" name="Text 21"/>
+          <p:cNvSpPr/>
+          <p:nvPr/>
+        </p:nvSpPr>
+        <p:spPr>
+          <a:xfrm>
+            <a:off x="7040880" y="3200400"/>
+            <a:ext cx="4510735" cy="320040"/>
+          </a:xfrm>
+          <a:prstGeom prst="rect">
+            <a:avLst/>
+          </a:prstGeom>
+          <a:noFill/>
+          <a:ln/>
+        </p:spPr>
+        <p:txBody>
+          <a:bodyPr wrap="square" rtlCol="0" anchor="ctr"/>
+          <a:lstStyle/>
+          <a:p>
+            <a:pPr indent="0" marL="0">
+              <a:buNone/>
+            </a:pPr>
+            <a:r>
+              <a:rPr lang="en-US" sz="1600" dirty="0">
+                <a:solidFill>
+                  <a:srgbClr val="2C332A"/>
+                </a:solidFill>
+                <a:latin typeface="Cambria" pitchFamily="34" charset="0"/>
+                <a:ea typeface="Cambria" pitchFamily="34" charset="-122"/>
+                <a:cs typeface="Cambria" pitchFamily="34" charset="-120"/>
+              </a:rPr>
+              <a:t>A heritage of tea</a:t>
+            </a:r>
+            <a:endParaRPr lang="en-US" sz="1600" dirty="0"/>
+          </a:p>
+        </p:txBody>
+      </p:sp>
+      <p:sp>
+        <p:nvSpPr>
+          <p:cNvPr id="24" name="Text 22"/>
+          <p:cNvSpPr/>
+          <p:nvPr/>
+        </p:nvSpPr>
+        <p:spPr>
+          <a:xfrm>
+            <a:off x="7040880" y="3557016"/>
+            <a:ext cx="4465015" cy="594360"/>
+          </a:xfrm>
+          <a:prstGeom prst="rect">
+            <a:avLst/>
+          </a:prstGeom>
+          <a:noFill/>
+          <a:ln/>
+        </p:spPr>
+        <p:txBody>
+          <a:bodyPr wrap="square" rtlCol="0" anchor="t"/>
+          <a:lstStyle/>
+          <a:p>
+            <a:pPr indent="0" marL="0">
+              <a:buNone/>
+            </a:pPr>
+            <a:r>
+              <a:rPr lang="en-US" sz="1250" dirty="0">
+                <a:solidFill>
+                  <a:srgbClr val="70776B"/>
+                </a:solidFill>
+                <a:latin typeface="Calibri" pitchFamily="34" charset="0"/>
+                <a:ea typeface="Calibri" pitchFamily="34" charset="-122"/>
+                <a:cs typeface="Calibri" pitchFamily="34" charset="-120"/>
+              </a:rPr>
+              <a:t>One of Japan’s oldest and most renowned tea-growing regions, cultivated for centuries.</a:t>
+            </a:r>
+            <a:endParaRPr lang="en-US" sz="1250" dirty="0"/>
+          </a:p>
+        </p:txBody>
+      </p:sp>
+      <p:sp>
+        <p:nvSpPr>
+          <p:cNvPr id="25" name="Shape 23"/>
+          <p:cNvSpPr/>
+          <p:nvPr/>
+        </p:nvSpPr>
+        <p:spPr>
+          <a:xfrm>
+            <a:off x="6446520" y="4197096"/>
+            <a:ext cx="402336" cy="402336"/>
+          </a:xfrm>
+          <a:prstGeom prst="ellipse">
+            <a:avLst/>
+          </a:prstGeom>
+          <a:solidFill>
+            <a:srgbClr val="5E7A3C"/>
+          </a:solidFill>
+          <a:ln/>
+        </p:spPr>
+      </p:sp>
+      <p:sp>
+        <p:nvSpPr>
+          <p:cNvPr id="26" name="Text 24"/>
+          <p:cNvSpPr/>
+          <p:nvPr/>
+        </p:nvSpPr>
+        <p:spPr>
+          <a:xfrm>
+            <a:off x="7040880" y="4114800"/>
+            <a:ext cx="4510735" cy="320040"/>
+          </a:xfrm>
+          <a:prstGeom prst="rect">
+            <a:avLst/>
+          </a:prstGeom>
+          <a:noFill/>
+          <a:ln/>
+        </p:spPr>
+        <p:txBody>
+          <a:bodyPr wrap="square" rtlCol="0" anchor="ctr"/>
+          <a:lstStyle/>
+          <a:p>
+            <a:pPr indent="0" marL="0">
+              <a:buNone/>
+            </a:pPr>
+            <a:r>
+              <a:rPr lang="en-US" sz="1600" dirty="0">
+                <a:solidFill>
+                  <a:srgbClr val="2C332A"/>
+                </a:solidFill>
+                <a:latin typeface="Cambria" pitchFamily="34" charset="0"/>
+                <a:ea typeface="Cambria" pitchFamily="34" charset="-122"/>
+                <a:cs typeface="Cambria" pitchFamily="34" charset="-120"/>
+              </a:rPr>
+              <a:t>Ideal terroir</a:t>
+            </a:r>
+            <a:endParaRPr lang="en-US" sz="1600" dirty="0"/>
+          </a:p>
+        </p:txBody>
+      </p:sp>
+      <p:sp>
+        <p:nvSpPr>
+          <p:cNvPr id="27" name="Text 25"/>
+          <p:cNvSpPr/>
+          <p:nvPr/>
+        </p:nvSpPr>
+        <p:spPr>
+          <a:xfrm>
+            <a:off x="7040880" y="4471416"/>
+            <a:ext cx="4465015" cy="594360"/>
+          </a:xfrm>
+          <a:prstGeom prst="rect">
+            <a:avLst/>
+          </a:prstGeom>
+          <a:noFill/>
+          <a:ln/>
+        </p:spPr>
+        <p:txBody>
+          <a:bodyPr wrap="square" rtlCol="0" anchor="t"/>
+          <a:lstStyle/>
+          <a:p>
+            <a:pPr indent="0" marL="0">
+              <a:buNone/>
+            </a:pPr>
+            <a:r>
+              <a:rPr lang="en-US" sz="1250" dirty="0">
+                <a:solidFill>
+                  <a:srgbClr val="70776B"/>
+                </a:solidFill>
+                <a:latin typeface="Calibri" pitchFamily="34" charset="0"/>
+                <a:ea typeface="Calibri" pitchFamily="34" charset="-122"/>
+                <a:cs typeface="Calibri" pitchFamily="34" charset="-120"/>
+              </a:rPr>
+              <a:t>Misty mountain slopes, a mild maritime climate, and well-drained volcanic soil.</a:t>
+            </a:r>
+            <a:endParaRPr lang="en-US" sz="1250" dirty="0"/>
+          </a:p>
+        </p:txBody>
+      </p:sp>
+      <p:sp>
+        <p:nvSpPr>
+          <p:cNvPr id="28" name="Shape 26"/>
+          <p:cNvSpPr/>
+          <p:nvPr/>
+        </p:nvSpPr>
+        <p:spPr>
+          <a:xfrm>
+            <a:off x="6446520" y="5111496"/>
+            <a:ext cx="402336" cy="402336"/>
+          </a:xfrm>
+          <a:prstGeom prst="ellipse">
+            <a:avLst/>
+          </a:prstGeom>
+          <a:solidFill>
+            <a:srgbClr val="5E7A3C"/>
+          </a:solidFill>
+          <a:ln/>
+        </p:spPr>
+      </p:sp>
+      <p:sp>
+        <p:nvSpPr>
+          <p:cNvPr id="29" name="Text 27"/>
+          <p:cNvSpPr/>
+          <p:nvPr/>
+        </p:nvSpPr>
+        <p:spPr>
+          <a:xfrm>
+            <a:off x="7040880" y="5029200"/>
+            <a:ext cx="4510735" cy="320040"/>
+          </a:xfrm>
+          <a:prstGeom prst="rect">
+            <a:avLst/>
+          </a:prstGeom>
+          <a:noFill/>
+          <a:ln/>
+        </p:spPr>
+        <p:txBody>
+          <a:bodyPr wrap="square" rtlCol="0" anchor="ctr"/>
+          <a:lstStyle/>
+          <a:p>
+            <a:pPr indent="0" marL="0">
+              <a:buNone/>
+            </a:pPr>
+            <a:r>
+              <a:rPr lang="en-US" sz="1600" dirty="0">
+                <a:solidFill>
+                  <a:srgbClr val="2C332A"/>
+                </a:solidFill>
+                <a:latin typeface="Cambria" pitchFamily="34" charset="0"/>
+                <a:ea typeface="Cambria" pitchFamily="34" charset="-122"/>
+                <a:cs typeface="Cambria" pitchFamily="34" charset="-120"/>
+              </a:rPr>
+              <a:t>A name buyers trust</a:t>
+            </a:r>
+            <a:endParaRPr lang="en-US" sz="1600" dirty="0"/>
+          </a:p>
+        </p:txBody>
+      </p:sp>
+      <p:sp>
+        <p:nvSpPr>
+          <p:cNvPr id="30" name="Text 28"/>
+          <p:cNvSpPr/>
+          <p:nvPr/>
+        </p:nvSpPr>
+        <p:spPr>
+          <a:xfrm>
+            <a:off x="7040880" y="5385816"/>
+            <a:ext cx="4465015" cy="594360"/>
+          </a:xfrm>
+          <a:prstGeom prst="rect">
+            <a:avLst/>
+          </a:prstGeom>
+          <a:noFill/>
+          <a:ln/>
+        </p:spPr>
+        <p:txBody>
+          <a:bodyPr wrap="square" rtlCol="0" anchor="t"/>
+          <a:lstStyle/>
+          <a:p>
+            <a:pPr indent="0" marL="0">
+              <a:buNone/>
+            </a:pPr>
+            <a:r>
+              <a:rPr lang="en-US" sz="1250" dirty="0">
+                <a:solidFill>
+                  <a:srgbClr val="70776B"/>
+                </a:solidFill>
+                <a:latin typeface="Calibri" pitchFamily="34" charset="0"/>
+                <a:ea typeface="Calibri" pitchFamily="34" charset="-122"/>
+                <a:cs typeface="Calibri" pitchFamily="34" charset="-120"/>
+              </a:rPr>
+              <a:t>In Japan, “Shizuoka” is synonymous with quality tea.</a:t>
+            </a:r>
+            <a:endParaRPr lang="en-US" sz="1250" dirty="0"/>
+          </a:p>
+        </p:txBody>
+      </p:sp>
+      <p:sp>
+        <p:nvSpPr>
+          <p:cNvPr id="31" name="Text 29"/>
+          <p:cNvSpPr/>
+          <p:nvPr/>
+        </p:nvSpPr>
+        <p:spPr>
+          <a:xfrm>
+            <a:off x="640080" y="6400800"/>
+            <a:ext cx="5486400" cy="274320"/>
+          </a:xfrm>
+          <a:prstGeom prst="rect">
+            <a:avLst/>
+          </a:prstGeom>
+          <a:noFill/>
+          <a:ln/>
+        </p:spPr>
+        <p:txBody>
+          <a:bodyPr wrap="square" rtlCol="0" anchor="ctr"/>
+          <a:lstStyle/>
+          <a:p>
+            <a:pPr algn="l" indent="0" marL="0">
+              <a:buNone/>
+            </a:pPr>
+            <a:r>
+              <a:rPr lang="en-US" sz="900" dirty="0">
+                <a:solidFill>
+                  <a:srgbClr val="70776B"/>
+                </a:solidFill>
+                <a:latin typeface="Calibri" pitchFamily="34" charset="0"/>
+                <a:ea typeface="Calibri" pitchFamily="34" charset="-122"/>
+                <a:cs typeface="Calibri" pitchFamily="34" charset="-120"/>
+              </a:rPr>
+              <a:t>SHIZUNE MATCHA  ·  Traverse Asia</a:t>
+            </a:r>
+            <a:endParaRPr lang="en-US" sz="900" dirty="0"/>
+          </a:p>
+        </p:txBody>
+      </p:sp>
+      <p:sp>
+        <p:nvSpPr>
+          <p:cNvPr id="32" name="Text 30"/>
+          <p:cNvSpPr/>
+          <p:nvPr/>
+        </p:nvSpPr>
+        <p:spPr>
+          <a:xfrm>
+            <a:off x="8808415" y="6400800"/>
+            <a:ext cx="2743200" cy="274320"/>
+          </a:xfrm>
+          <a:prstGeom prst="rect">
+            <a:avLst/>
+          </a:prstGeom>
+          <a:noFill/>
+          <a:ln/>
+        </p:spPr>
+        <p:txBody>
+          <a:bodyPr wrap="square" rtlCol="0" anchor="ctr"/>
+          <a:lstStyle/>
+          <a:p>
+            <a:pPr algn="r" indent="0" marL="0">
+              <a:buNone/>
+            </a:pPr>
+            <a:r>
+              <a:rPr lang="en-US" sz="900" dirty="0">
+                <a:solidFill>
+                  <a:srgbClr val="70776B"/>
+                </a:solidFill>
+                <a:latin typeface="Calibri" pitchFamily="34" charset="0"/>
+                <a:ea typeface="Calibri" pitchFamily="34" charset="-122"/>
+                <a:cs typeface="Calibri" pitchFamily="34" charset="-120"/>
+              </a:rPr>
+              <a:t>shizunematcha.com</a:t>
+            </a:r>
+            <a:endParaRPr lang="en-US" sz="900" dirty="0"/>
+          </a:p>
+        </p:txBody>
+      </p:sp>
+    </p:spTree>
+  </p:cSld>
+  <p:clrMapOvr>
+    <a:masterClrMapping/>
+  </p:clrMapOvr>
+</p:sld>
+</file>
+
+<file path=ppt/slides/slide5.xml><?xml version="1.0" encoding="utf-8"?>
+<p:sld xmlns:a="http://schemas.openxmlformats.org/drawingml/2006/main" xmlns:r="http://schemas.openxmlformats.org/officeDocument/2006/relationships" xmlns:p="http://schemas.openxmlformats.org/presentationml/2006/main">
+  <p:cSld name="Slide 5">
+    <p:bg>
+      <p:bgPr>
+        <a:solidFill>
           <a:srgbClr val="F6F4EC"/>
         </a:solidFill>
       </p:bgPr>
@@ -5798,7 +8182,7 @@
                 <a:ea typeface="Calibri" pitchFamily="34" charset="-122"/>
                 <a:cs typeface="Calibri" pitchFamily="34" charset="-120"/>
               </a:rPr>
-              <a:t>04</a:t>
+              <a:t>05</a:t>
             </a:r>
             <a:endParaRPr lang="en-US" sz="1000" dirty="0"/>
           </a:p>
@@ -6568,9 +8952,9 @@
 </p:sld>
 </file>
 
-<file path=ppt/slides/slide5.xml><?xml version="1.0" encoding="utf-8"?>
+<file path=ppt/slides/slide6.xml><?xml version="1.0" encoding="utf-8"?>
 <p:sld xmlns:a="http://schemas.openxmlformats.org/drawingml/2006/main" xmlns:r="http://schemas.openxmlformats.org/officeDocument/2006/relationships" xmlns:p="http://schemas.openxmlformats.org/presentationml/2006/main">
-  <p:cSld name="Slide 5">
+  <p:cSld name="Slide 6">
     <p:bg>
       <p:bgPr>
         <a:solidFill>
@@ -6684,7 +9068,7 @@
                 <a:ea typeface="Calibri" pitchFamily="34" charset="-122"/>
                 <a:cs typeface="Calibri" pitchFamily="34" charset="-120"/>
               </a:rPr>
-              <a:t>05</a:t>
+              <a:t>06</a:t>
             </a:r>
             <a:endParaRPr lang="en-US" sz="1000" dirty="0"/>
           </a:p>
@@ -7460,9 +9844,9 @@
 </p:sld>
 </file>
 
-<file path=ppt/slides/slide6.xml><?xml version="1.0" encoding="utf-8"?>
+<file path=ppt/slides/slide7.xml><?xml version="1.0" encoding="utf-8"?>
 <p:sld xmlns:a="http://schemas.openxmlformats.org/drawingml/2006/main" xmlns:r="http://schemas.openxmlformats.org/officeDocument/2006/relationships" xmlns:p="http://schemas.openxmlformats.org/presentationml/2006/main">
-  <p:cSld name="Slide 6">
+  <p:cSld name="Slide 7">
     <p:bg>
       <p:bgPr>
         <a:solidFill>
@@ -7576,7 +9960,7 @@
                 <a:ea typeface="Calibri" pitchFamily="34" charset="-122"/>
                 <a:cs typeface="Calibri" pitchFamily="34" charset="-120"/>
               </a:rPr>
-              <a:t>06</a:t>
+              <a:t>07</a:t>
             </a:r>
             <a:endParaRPr lang="en-US" sz="1000" dirty="0"/>
           </a:p>
@@ -8513,9 +10897,9 @@
 </p:sld>
 </file>
 
-<file path=ppt/slides/slide7.xml><?xml version="1.0" encoding="utf-8"?>
+<file path=ppt/slides/slide8.xml><?xml version="1.0" encoding="utf-8"?>
 <p:sld xmlns:a="http://schemas.openxmlformats.org/drawingml/2006/main" xmlns:r="http://schemas.openxmlformats.org/officeDocument/2006/relationships" xmlns:p="http://schemas.openxmlformats.org/presentationml/2006/main">
-  <p:cSld name="Slide 7">
+  <p:cSld name="Slide 8">
     <p:bg>
       <p:bgPr>
         <a:solidFill>
@@ -8629,7 +11013,7 @@
                 <a:ea typeface="Calibri" pitchFamily="34" charset="-122"/>
                 <a:cs typeface="Calibri" pitchFamily="34" charset="-120"/>
               </a:rPr>
-              <a:t>07</a:t>
+              <a:t>08</a:t>
             </a:r>
             <a:endParaRPr lang="en-US" sz="1000" dirty="0"/>
           </a:p>
@@ -9543,9 +11927,9 @@
 </p:sld>
 </file>
 
-<file path=ppt/slides/slide8.xml><?xml version="1.0" encoding="utf-8"?>
+<file path=ppt/slides/slide9.xml><?xml version="1.0" encoding="utf-8"?>
 <p:sld xmlns:a="http://schemas.openxmlformats.org/drawingml/2006/main" xmlns:r="http://schemas.openxmlformats.org/officeDocument/2006/relationships" xmlns:p="http://schemas.openxmlformats.org/presentationml/2006/main">
-  <p:cSld name="Slide 8">
+  <p:cSld name="Slide 9">
     <p:bg>
       <p:bgPr>
         <a:solidFill>
@@ -9659,7 +12043,7 @@
                 <a:ea typeface="Calibri" pitchFamily="34" charset="-122"/>
                 <a:cs typeface="Calibri" pitchFamily="34" charset="-120"/>
               </a:rPr>
-              <a:t>08</a:t>
+              <a:t>09</a:t>
             </a:r>
             <a:endParaRPr lang="en-US" sz="1000" dirty="0"/>
           </a:p>
@@ -10466,1276 +12850,6 @@
       <p:sp>
         <p:nvSpPr>
           <p:cNvPr id="25" name="Text 23"/>
-          <p:cNvSpPr/>
-          <p:nvPr/>
-        </p:nvSpPr>
-        <p:spPr>
-          <a:xfrm>
-            <a:off x="8808415" y="6400800"/>
-            <a:ext cx="2743200" cy="274320"/>
-          </a:xfrm>
-          <a:prstGeom prst="rect">
-            <a:avLst/>
-          </a:prstGeom>
-          <a:noFill/>
-          <a:ln/>
-        </p:spPr>
-        <p:txBody>
-          <a:bodyPr wrap="square" rtlCol="0" anchor="ctr"/>
-          <a:lstStyle/>
-          <a:p>
-            <a:pPr algn="r" indent="0" marL="0">
-              <a:buNone/>
-            </a:pPr>
-            <a:r>
-              <a:rPr lang="en-US" sz="900" dirty="0">
-                <a:solidFill>
-                  <a:srgbClr val="70776B"/>
-                </a:solidFill>
-                <a:latin typeface="Calibri" pitchFamily="34" charset="0"/>
-                <a:ea typeface="Calibri" pitchFamily="34" charset="-122"/>
-                <a:cs typeface="Calibri" pitchFamily="34" charset="-120"/>
-              </a:rPr>
-              <a:t>shizunematcha.com</a:t>
-            </a:r>
-            <a:endParaRPr lang="en-US" sz="900" dirty="0"/>
-          </a:p>
-        </p:txBody>
-      </p:sp>
-    </p:spTree>
-  </p:cSld>
-  <p:clrMapOvr>
-    <a:masterClrMapping/>
-  </p:clrMapOvr>
-</p:sld>
-</file>
-
-<file path=ppt/slides/slide9.xml><?xml version="1.0" encoding="utf-8"?>
-<p:sld xmlns:a="http://schemas.openxmlformats.org/drawingml/2006/main" xmlns:r="http://schemas.openxmlformats.org/officeDocument/2006/relationships" xmlns:p="http://schemas.openxmlformats.org/presentationml/2006/main">
-  <p:cSld name="Slide 9">
-    <p:bg>
-      <p:bgPr>
-        <a:solidFill>
-          <a:srgbClr val="FFFFFF"/>
-        </a:solidFill>
-      </p:bgPr>
-    </p:bg>
-    <p:spTree>
-      <p:nvGrpSpPr>
-        <p:cNvPr id="1" name=""/>
-        <p:cNvGrpSpPr/>
-        <p:nvPr/>
-      </p:nvGrpSpPr>
-      <p:grpSpPr>
-        <a:xfrm>
-          <a:off x="0" y="0"/>
-          <a:ext cx="0" cy="0"/>
-          <a:chOff x="0" y="0"/>
-          <a:chExt cx="0" cy="0"/>
-        </a:xfrm>
-      </p:grpSpPr>
-      <p:sp>
-        <p:nvSpPr>
-          <p:cNvPr id="2" name="Shape 0"/>
-          <p:cNvSpPr/>
-          <p:nvPr/>
-        </p:nvSpPr>
-        <p:spPr>
-          <a:xfrm>
-            <a:off x="640080" y="667512"/>
-            <a:ext cx="109728" cy="109728"/>
-          </a:xfrm>
-          <a:prstGeom prst="ellipse">
-            <a:avLst/>
-          </a:prstGeom>
-          <a:solidFill>
-            <a:srgbClr val="5E7A3C"/>
-          </a:solidFill>
-          <a:ln/>
-        </p:spPr>
-      </p:sp>
-      <p:sp>
-        <p:nvSpPr>
-          <p:cNvPr id="3" name="Text 1"/>
-          <p:cNvSpPr/>
-          <p:nvPr/>
-        </p:nvSpPr>
-        <p:spPr>
-          <a:xfrm>
-            <a:off x="841248" y="603504"/>
-            <a:ext cx="5486400" cy="256032"/>
-          </a:xfrm>
-          <a:prstGeom prst="rect">
-            <a:avLst/>
-          </a:prstGeom>
-          <a:noFill/>
-          <a:ln/>
-        </p:spPr>
-        <p:txBody>
-          <a:bodyPr wrap="square" rtlCol="0" anchor="ctr"/>
-          <a:lstStyle/>
-          <a:p>
-            <a:pPr algn="l" indent="0" marL="0">
-              <a:buNone/>
-            </a:pPr>
-            <a:r>
-              <a:rPr lang="en-US" sz="1100" b="1" spc="200" kern="0" dirty="0">
-                <a:solidFill>
-                  <a:srgbClr val="5E7A3C"/>
-                </a:solidFill>
-                <a:latin typeface="Calibri" pitchFamily="34" charset="0"/>
-                <a:ea typeface="Calibri" pitchFamily="34" charset="-122"/>
-                <a:cs typeface="Calibri" pitchFamily="34" charset="-120"/>
-              </a:rPr>
-              <a:t>WHOLESALE TERMS</a:t>
-            </a:r>
-            <a:endParaRPr lang="en-US" sz="1100" dirty="0"/>
-          </a:p>
-        </p:txBody>
-      </p:sp>
-      <p:sp>
-        <p:nvSpPr>
-          <p:cNvPr id="4" name="Text 2"/>
-          <p:cNvSpPr/>
-          <p:nvPr/>
-        </p:nvSpPr>
-        <p:spPr>
-          <a:xfrm>
-            <a:off x="10820095" y="502920"/>
-            <a:ext cx="731520" cy="274320"/>
-          </a:xfrm>
-          <a:prstGeom prst="rect">
-            <a:avLst/>
-          </a:prstGeom>
-          <a:noFill/>
-          <a:ln/>
-        </p:spPr>
-        <p:txBody>
-          <a:bodyPr wrap="square" rtlCol="0" anchor="ctr"/>
-          <a:lstStyle/>
-          <a:p>
-            <a:pPr algn="r" indent="0" marL="0">
-              <a:buNone/>
-            </a:pPr>
-            <a:r>
-              <a:rPr lang="en-US" sz="1000" b="1" dirty="0">
-                <a:solidFill>
-                  <a:srgbClr val="9DAE86"/>
-                </a:solidFill>
-                <a:latin typeface="Calibri" pitchFamily="34" charset="0"/>
-                <a:ea typeface="Calibri" pitchFamily="34" charset="-122"/>
-                <a:cs typeface="Calibri" pitchFamily="34" charset="-120"/>
-              </a:rPr>
-              <a:t>09</a:t>
-            </a:r>
-            <a:endParaRPr lang="en-US" sz="1000" dirty="0"/>
-          </a:p>
-        </p:txBody>
-      </p:sp>
-      <p:sp>
-        <p:nvSpPr>
-          <p:cNvPr id="5" name="Text 3"/>
-          <p:cNvSpPr/>
-          <p:nvPr/>
-        </p:nvSpPr>
-        <p:spPr>
-          <a:xfrm>
-            <a:off x="640080" y="1097280"/>
-            <a:ext cx="10515600" cy="640080"/>
-          </a:xfrm>
-          <a:prstGeom prst="rect">
-            <a:avLst/>
-          </a:prstGeom>
-          <a:noFill/>
-          <a:ln/>
-        </p:spPr>
-        <p:txBody>
-          <a:bodyPr wrap="square" rtlCol="0" anchor="ctr"/>
-          <a:lstStyle/>
-          <a:p>
-            <a:pPr indent="0" marL="0">
-              <a:buNone/>
-            </a:pPr>
-            <a:r>
-              <a:rPr lang="en-US" sz="3400" dirty="0">
-                <a:solidFill>
-                  <a:srgbClr val="2C332A"/>
-                </a:solidFill>
-                <a:latin typeface="Cambria" pitchFamily="34" charset="0"/>
-                <a:ea typeface="Cambria" pitchFamily="34" charset="-122"/>
-                <a:cs typeface="Cambria" pitchFamily="34" charset="-120"/>
-              </a:rPr>
-              <a:t>Simple terms to get started.</a:t>
-            </a:r>
-            <a:endParaRPr lang="en-US" sz="3400" dirty="0"/>
-          </a:p>
-        </p:txBody>
-      </p:sp>
-      <p:sp>
-        <p:nvSpPr>
-          <p:cNvPr id="6" name="Shape 4"/>
-          <p:cNvSpPr/>
-          <p:nvPr/>
-        </p:nvSpPr>
-        <p:spPr>
-          <a:xfrm>
-            <a:off x="640080" y="1920240"/>
-            <a:ext cx="5227168" cy="1188720"/>
-          </a:xfrm>
-          <a:prstGeom prst="roundRect">
-            <a:avLst>
-              <a:gd name="adj" fmla="val 6154"/>
-            </a:avLst>
-          </a:prstGeom>
-          <a:solidFill>
-            <a:srgbClr val="F6F4EC"/>
-          </a:solidFill>
-          <a:ln w="12700">
-            <a:solidFill>
-              <a:srgbClr val="E2DFD4"/>
-            </a:solidFill>
-            <a:prstDash val="solid"/>
-          </a:ln>
-        </p:spPr>
-      </p:sp>
-      <p:sp>
-        <p:nvSpPr>
-          <p:cNvPr id="7" name="Shape 5"/>
-          <p:cNvSpPr/>
-          <p:nvPr/>
-        </p:nvSpPr>
-        <p:spPr>
-          <a:xfrm>
-            <a:off x="960120" y="2240280"/>
-            <a:ext cx="566928" cy="566928"/>
-          </a:xfrm>
-          <a:prstGeom prst="ellipse">
-            <a:avLst/>
-          </a:prstGeom>
-          <a:solidFill>
-            <a:srgbClr val="5E7A3C"/>
-          </a:solidFill>
-          <a:ln/>
-        </p:spPr>
-      </p:sp>
-      <p:sp>
-        <p:nvSpPr>
-          <p:cNvPr id="8" name="Text 6"/>
-          <p:cNvSpPr/>
-          <p:nvPr/>
-        </p:nvSpPr>
-        <p:spPr>
-          <a:xfrm>
-            <a:off x="960120" y="2240280"/>
-            <a:ext cx="566928" cy="566928"/>
-          </a:xfrm>
-          <a:prstGeom prst="rect">
-            <a:avLst/>
-          </a:prstGeom>
-          <a:noFill/>
-          <a:ln/>
-        </p:spPr>
-        <p:txBody>
-          <a:bodyPr wrap="square" rtlCol="0" anchor="ctr"/>
-          <a:lstStyle/>
-          <a:p>
-            <a:pPr algn="ctr" indent="0" marL="0">
-              <a:buNone/>
-            </a:pPr>
-            <a:r>
-              <a:rPr lang="en-US" sz="2200" b="1" dirty="0">
-                <a:solidFill>
-                  <a:srgbClr val="FFFFFF"/>
-                </a:solidFill>
-                <a:latin typeface="Cambria" pitchFamily="34" charset="0"/>
-                <a:ea typeface="Cambria" pitchFamily="34" charset="-122"/>
-                <a:cs typeface="Cambria" pitchFamily="34" charset="-120"/>
-              </a:rPr>
-              <a:t>M</a:t>
-            </a:r>
-            <a:endParaRPr lang="en-US" sz="2200" dirty="0"/>
-          </a:p>
-        </p:txBody>
-      </p:sp>
-      <p:sp>
-        <p:nvSpPr>
-          <p:cNvPr id="9" name="Text 7"/>
-          <p:cNvSpPr/>
-          <p:nvPr/>
-        </p:nvSpPr>
-        <p:spPr>
-          <a:xfrm>
-            <a:off x="1737360" y="2139696"/>
-            <a:ext cx="3947008" cy="320040"/>
-          </a:xfrm>
-          <a:prstGeom prst="rect">
-            <a:avLst/>
-          </a:prstGeom>
-          <a:noFill/>
-          <a:ln/>
-        </p:spPr>
-        <p:txBody>
-          <a:bodyPr wrap="square" rtlCol="0" anchor="ctr"/>
-          <a:lstStyle/>
-          <a:p>
-            <a:pPr indent="0" marL="0">
-              <a:buNone/>
-            </a:pPr>
-            <a:r>
-              <a:rPr lang="en-US" sz="1250" b="1" spc="100" kern="0" dirty="0">
-                <a:solidFill>
-                  <a:srgbClr val="47602D"/>
-                </a:solidFill>
-                <a:latin typeface="Calibri" pitchFamily="34" charset="0"/>
-                <a:ea typeface="Calibri" pitchFamily="34" charset="-122"/>
-                <a:cs typeface="Calibri" pitchFamily="34" charset="-120"/>
-              </a:rPr>
-              <a:t>MOQ</a:t>
-            </a:r>
-            <a:endParaRPr lang="en-US" sz="1250" dirty="0"/>
-          </a:p>
-        </p:txBody>
-      </p:sp>
-      <p:sp>
-        <p:nvSpPr>
-          <p:cNvPr id="10" name="Text 8"/>
-          <p:cNvSpPr/>
-          <p:nvPr/>
-        </p:nvSpPr>
-        <p:spPr>
-          <a:xfrm>
-            <a:off x="1737360" y="2468880"/>
-            <a:ext cx="3901288" cy="594360"/>
-          </a:xfrm>
-          <a:prstGeom prst="rect">
-            <a:avLst/>
-          </a:prstGeom>
-          <a:noFill/>
-          <a:ln/>
-        </p:spPr>
-        <p:txBody>
-          <a:bodyPr wrap="square" rtlCol="0" anchor="t"/>
-          <a:lstStyle/>
-          <a:p>
-            <a:pPr indent="0" marL="0">
-              <a:buNone/>
-            </a:pPr>
-            <a:r>
-              <a:rPr lang="en-US" sz="1200" dirty="0">
-                <a:solidFill>
-                  <a:srgbClr val="2C332A"/>
-                </a:solidFill>
-                <a:latin typeface="Calibri" pitchFamily="34" charset="0"/>
-                <a:ea typeface="Calibri" pitchFamily="34" charset="-122"/>
-                <a:cs typeface="Calibri" pitchFamily="34" charset="-120"/>
-              </a:rPr>
-              <a:t>Bulk: 1 kg   ·   Finished SKUs: 3 cases (opening order)</a:t>
-            </a:r>
-            <a:endParaRPr lang="en-US" sz="1200" dirty="0"/>
-          </a:p>
-        </p:txBody>
-      </p:sp>
-      <p:sp>
-        <p:nvSpPr>
-          <p:cNvPr id="11" name="Shape 9"/>
-          <p:cNvSpPr/>
-          <p:nvPr/>
-        </p:nvSpPr>
-        <p:spPr>
-          <a:xfrm>
-            <a:off x="6324448" y="1920240"/>
-            <a:ext cx="5227168" cy="1188720"/>
-          </a:xfrm>
-          <a:prstGeom prst="roundRect">
-            <a:avLst>
-              <a:gd name="adj" fmla="val 6154"/>
-            </a:avLst>
-          </a:prstGeom>
-          <a:solidFill>
-            <a:srgbClr val="F6F4EC"/>
-          </a:solidFill>
-          <a:ln w="12700">
-            <a:solidFill>
-              <a:srgbClr val="E2DFD4"/>
-            </a:solidFill>
-            <a:prstDash val="solid"/>
-          </a:ln>
-        </p:spPr>
-      </p:sp>
-      <p:sp>
-        <p:nvSpPr>
-          <p:cNvPr id="12" name="Shape 10"/>
-          <p:cNvSpPr/>
-          <p:nvPr/>
-        </p:nvSpPr>
-        <p:spPr>
-          <a:xfrm>
-            <a:off x="6644488" y="2240280"/>
-            <a:ext cx="566928" cy="566928"/>
-          </a:xfrm>
-          <a:prstGeom prst="ellipse">
-            <a:avLst/>
-          </a:prstGeom>
-          <a:solidFill>
-            <a:srgbClr val="5E7A3C"/>
-          </a:solidFill>
-          <a:ln/>
-        </p:spPr>
-      </p:sp>
-      <p:sp>
-        <p:nvSpPr>
-          <p:cNvPr id="13" name="Text 11"/>
-          <p:cNvSpPr/>
-          <p:nvPr/>
-        </p:nvSpPr>
-        <p:spPr>
-          <a:xfrm>
-            <a:off x="6644488" y="2240280"/>
-            <a:ext cx="566928" cy="566928"/>
-          </a:xfrm>
-          <a:prstGeom prst="rect">
-            <a:avLst/>
-          </a:prstGeom>
-          <a:noFill/>
-          <a:ln/>
-        </p:spPr>
-        <p:txBody>
-          <a:bodyPr wrap="square" rtlCol="0" anchor="ctr"/>
-          <a:lstStyle/>
-          <a:p>
-            <a:pPr algn="ctr" indent="0" marL="0">
-              <a:buNone/>
-            </a:pPr>
-            <a:r>
-              <a:rPr lang="en-US" sz="2200" b="1" dirty="0">
-                <a:solidFill>
-                  <a:srgbClr val="FFFFFF"/>
-                </a:solidFill>
-                <a:latin typeface="Cambria" pitchFamily="34" charset="0"/>
-                <a:ea typeface="Cambria" pitchFamily="34" charset="-122"/>
-                <a:cs typeface="Cambria" pitchFamily="34" charset="-120"/>
-              </a:rPr>
-              <a:t>C</a:t>
-            </a:r>
-            <a:endParaRPr lang="en-US" sz="2200" dirty="0"/>
-          </a:p>
-        </p:txBody>
-      </p:sp>
-      <p:sp>
-        <p:nvSpPr>
-          <p:cNvPr id="14" name="Text 12"/>
-          <p:cNvSpPr/>
-          <p:nvPr/>
-        </p:nvSpPr>
-        <p:spPr>
-          <a:xfrm>
-            <a:off x="7421728" y="2139696"/>
-            <a:ext cx="3947008" cy="320040"/>
-          </a:xfrm>
-          <a:prstGeom prst="rect">
-            <a:avLst/>
-          </a:prstGeom>
-          <a:noFill/>
-          <a:ln/>
-        </p:spPr>
-        <p:txBody>
-          <a:bodyPr wrap="square" rtlCol="0" anchor="ctr"/>
-          <a:lstStyle/>
-          <a:p>
-            <a:pPr indent="0" marL="0">
-              <a:buNone/>
-            </a:pPr>
-            <a:r>
-              <a:rPr lang="en-US" sz="1250" b="1" spc="100" kern="0" dirty="0">
-                <a:solidFill>
-                  <a:srgbClr val="47602D"/>
-                </a:solidFill>
-                <a:latin typeface="Calibri" pitchFamily="34" charset="0"/>
-                <a:ea typeface="Calibri" pitchFamily="34" charset="-122"/>
-                <a:cs typeface="Calibri" pitchFamily="34" charset="-120"/>
-              </a:rPr>
-              <a:t>Case pack</a:t>
-            </a:r>
-            <a:endParaRPr lang="en-US" sz="1250" dirty="0"/>
-          </a:p>
-        </p:txBody>
-      </p:sp>
-      <p:sp>
-        <p:nvSpPr>
-          <p:cNvPr id="15" name="Text 13"/>
-          <p:cNvSpPr/>
-          <p:nvPr/>
-        </p:nvSpPr>
-        <p:spPr>
-          <a:xfrm>
-            <a:off x="7421728" y="2468880"/>
-            <a:ext cx="3901288" cy="594360"/>
-          </a:xfrm>
-          <a:prstGeom prst="rect">
-            <a:avLst/>
-          </a:prstGeom>
-          <a:noFill/>
-          <a:ln/>
-        </p:spPr>
-        <p:txBody>
-          <a:bodyPr wrap="square" rtlCol="0" anchor="t"/>
-          <a:lstStyle/>
-          <a:p>
-            <a:pPr indent="0" marL="0">
-              <a:buNone/>
-            </a:pPr>
-            <a:r>
-              <a:rPr lang="en-US" sz="1200" dirty="0">
-                <a:solidFill>
-                  <a:srgbClr val="2C332A"/>
-                </a:solidFill>
-                <a:latin typeface="Calibri" pitchFamily="34" charset="0"/>
-                <a:ea typeface="Calibri" pitchFamily="34" charset="-122"/>
-                <a:cs typeface="Calibri" pitchFamily="34" charset="-120"/>
-              </a:rPr>
-              <a:t>12 units per case</a:t>
-            </a:r>
-            <a:endParaRPr lang="en-US" sz="1200" dirty="0"/>
-          </a:p>
-        </p:txBody>
-      </p:sp>
-      <p:sp>
-        <p:nvSpPr>
-          <p:cNvPr id="16" name="Shape 14"/>
-          <p:cNvSpPr/>
-          <p:nvPr/>
-        </p:nvSpPr>
-        <p:spPr>
-          <a:xfrm>
-            <a:off x="640080" y="3364992"/>
-            <a:ext cx="5227168" cy="1188720"/>
-          </a:xfrm>
-          <a:prstGeom prst="roundRect">
-            <a:avLst>
-              <a:gd name="adj" fmla="val 6154"/>
-            </a:avLst>
-          </a:prstGeom>
-          <a:solidFill>
-            <a:srgbClr val="F6F4EC"/>
-          </a:solidFill>
-          <a:ln w="12700">
-            <a:solidFill>
-              <a:srgbClr val="E2DFD4"/>
-            </a:solidFill>
-            <a:prstDash val="solid"/>
-          </a:ln>
-        </p:spPr>
-      </p:sp>
-      <p:sp>
-        <p:nvSpPr>
-          <p:cNvPr id="17" name="Shape 15"/>
-          <p:cNvSpPr/>
-          <p:nvPr/>
-        </p:nvSpPr>
-        <p:spPr>
-          <a:xfrm>
-            <a:off x="960120" y="3685032"/>
-            <a:ext cx="566928" cy="566928"/>
-          </a:xfrm>
-          <a:prstGeom prst="ellipse">
-            <a:avLst/>
-          </a:prstGeom>
-          <a:solidFill>
-            <a:srgbClr val="5E7A3C"/>
-          </a:solidFill>
-          <a:ln/>
-        </p:spPr>
-      </p:sp>
-      <p:sp>
-        <p:nvSpPr>
-          <p:cNvPr id="18" name="Text 16"/>
-          <p:cNvSpPr/>
-          <p:nvPr/>
-        </p:nvSpPr>
-        <p:spPr>
-          <a:xfrm>
-            <a:off x="960120" y="3685032"/>
-            <a:ext cx="566928" cy="566928"/>
-          </a:xfrm>
-          <a:prstGeom prst="rect">
-            <a:avLst/>
-          </a:prstGeom>
-          <a:noFill/>
-          <a:ln/>
-        </p:spPr>
-        <p:txBody>
-          <a:bodyPr wrap="square" rtlCol="0" anchor="ctr"/>
-          <a:lstStyle/>
-          <a:p>
-            <a:pPr algn="ctr" indent="0" marL="0">
-              <a:buNone/>
-            </a:pPr>
-            <a:r>
-              <a:rPr lang="en-US" sz="2200" b="1" dirty="0">
-                <a:solidFill>
-                  <a:srgbClr val="FFFFFF"/>
-                </a:solidFill>
-                <a:latin typeface="Cambria" pitchFamily="34" charset="0"/>
-                <a:ea typeface="Cambria" pitchFamily="34" charset="-122"/>
-                <a:cs typeface="Cambria" pitchFamily="34" charset="-120"/>
-              </a:rPr>
-              <a:t>L</a:t>
-            </a:r>
-            <a:endParaRPr lang="en-US" sz="2200" dirty="0"/>
-          </a:p>
-        </p:txBody>
-      </p:sp>
-      <p:sp>
-        <p:nvSpPr>
-          <p:cNvPr id="19" name="Text 17"/>
-          <p:cNvSpPr/>
-          <p:nvPr/>
-        </p:nvSpPr>
-        <p:spPr>
-          <a:xfrm>
-            <a:off x="1737360" y="3584448"/>
-            <a:ext cx="3947008" cy="320040"/>
-          </a:xfrm>
-          <a:prstGeom prst="rect">
-            <a:avLst/>
-          </a:prstGeom>
-          <a:noFill/>
-          <a:ln/>
-        </p:spPr>
-        <p:txBody>
-          <a:bodyPr wrap="square" rtlCol="0" anchor="ctr"/>
-          <a:lstStyle/>
-          <a:p>
-            <a:pPr indent="0" marL="0">
-              <a:buNone/>
-            </a:pPr>
-            <a:r>
-              <a:rPr lang="en-US" sz="1250" b="1" spc="100" kern="0" dirty="0">
-                <a:solidFill>
-                  <a:srgbClr val="47602D"/>
-                </a:solidFill>
-                <a:latin typeface="Calibri" pitchFamily="34" charset="0"/>
-                <a:ea typeface="Calibri" pitchFamily="34" charset="-122"/>
-                <a:cs typeface="Calibri" pitchFamily="34" charset="-120"/>
-              </a:rPr>
-              <a:t>Lead time</a:t>
-            </a:r>
-            <a:endParaRPr lang="en-US" sz="1250" dirty="0"/>
-          </a:p>
-        </p:txBody>
-      </p:sp>
-      <p:sp>
-        <p:nvSpPr>
-          <p:cNvPr id="20" name="Text 18"/>
-          <p:cNvSpPr/>
-          <p:nvPr/>
-        </p:nvSpPr>
-        <p:spPr>
-          <a:xfrm>
-            <a:off x="1737360" y="3913632"/>
-            <a:ext cx="3901288" cy="594360"/>
-          </a:xfrm>
-          <a:prstGeom prst="rect">
-            <a:avLst/>
-          </a:prstGeom>
-          <a:noFill/>
-          <a:ln/>
-        </p:spPr>
-        <p:txBody>
-          <a:bodyPr wrap="square" rtlCol="0" anchor="t"/>
-          <a:lstStyle/>
-          <a:p>
-            <a:pPr indent="0" marL="0">
-              <a:buNone/>
-            </a:pPr>
-            <a:r>
-              <a:rPr lang="en-US" sz="1200" dirty="0">
-                <a:solidFill>
-                  <a:srgbClr val="2C332A"/>
-                </a:solidFill>
-                <a:latin typeface="Calibri" pitchFamily="34" charset="0"/>
-                <a:ea typeface="Calibri" pitchFamily="34" charset="-122"/>
-                <a:cs typeface="Calibri" pitchFamily="34" charset="-120"/>
-              </a:rPr>
-              <a:t>Finished SKUs: 10 days   ·   Bulk: 2–3 weeks (made to order)</a:t>
-            </a:r>
-            <a:endParaRPr lang="en-US" sz="1200" dirty="0"/>
-          </a:p>
-        </p:txBody>
-      </p:sp>
-      <p:sp>
-        <p:nvSpPr>
-          <p:cNvPr id="21" name="Shape 19"/>
-          <p:cNvSpPr/>
-          <p:nvPr/>
-        </p:nvSpPr>
-        <p:spPr>
-          <a:xfrm>
-            <a:off x="6324448" y="3364992"/>
-            <a:ext cx="5227168" cy="1188720"/>
-          </a:xfrm>
-          <a:prstGeom prst="roundRect">
-            <a:avLst>
-              <a:gd name="adj" fmla="val 6154"/>
-            </a:avLst>
-          </a:prstGeom>
-          <a:solidFill>
-            <a:srgbClr val="F6F4EC"/>
-          </a:solidFill>
-          <a:ln w="12700">
-            <a:solidFill>
-              <a:srgbClr val="E2DFD4"/>
-            </a:solidFill>
-            <a:prstDash val="solid"/>
-          </a:ln>
-        </p:spPr>
-      </p:sp>
-      <p:sp>
-        <p:nvSpPr>
-          <p:cNvPr id="22" name="Shape 20"/>
-          <p:cNvSpPr/>
-          <p:nvPr/>
-        </p:nvSpPr>
-        <p:spPr>
-          <a:xfrm>
-            <a:off x="6644488" y="3685032"/>
-            <a:ext cx="566928" cy="566928"/>
-          </a:xfrm>
-          <a:prstGeom prst="ellipse">
-            <a:avLst/>
-          </a:prstGeom>
-          <a:solidFill>
-            <a:srgbClr val="5E7A3C"/>
-          </a:solidFill>
-          <a:ln/>
-        </p:spPr>
-      </p:sp>
-      <p:sp>
-        <p:nvSpPr>
-          <p:cNvPr id="23" name="Text 21"/>
-          <p:cNvSpPr/>
-          <p:nvPr/>
-        </p:nvSpPr>
-        <p:spPr>
-          <a:xfrm>
-            <a:off x="6644488" y="3685032"/>
-            <a:ext cx="566928" cy="566928"/>
-          </a:xfrm>
-          <a:prstGeom prst="rect">
-            <a:avLst/>
-          </a:prstGeom>
-          <a:noFill/>
-          <a:ln/>
-        </p:spPr>
-        <p:txBody>
-          <a:bodyPr wrap="square" rtlCol="0" anchor="ctr"/>
-          <a:lstStyle/>
-          <a:p>
-            <a:pPr algn="ctr" indent="0" marL="0">
-              <a:buNone/>
-            </a:pPr>
-            <a:r>
-              <a:rPr lang="en-US" sz="2200" b="1" dirty="0">
-                <a:solidFill>
-                  <a:srgbClr val="FFFFFF"/>
-                </a:solidFill>
-                <a:latin typeface="Cambria" pitchFamily="34" charset="0"/>
-                <a:ea typeface="Cambria" pitchFamily="34" charset="-122"/>
-                <a:cs typeface="Cambria" pitchFamily="34" charset="-120"/>
-              </a:rPr>
-              <a:t>S</a:t>
-            </a:r>
-            <a:endParaRPr lang="en-US" sz="2200" dirty="0"/>
-          </a:p>
-        </p:txBody>
-      </p:sp>
-      <p:sp>
-        <p:nvSpPr>
-          <p:cNvPr id="24" name="Text 22"/>
-          <p:cNvSpPr/>
-          <p:nvPr/>
-        </p:nvSpPr>
-        <p:spPr>
-          <a:xfrm>
-            <a:off x="7421728" y="3584448"/>
-            <a:ext cx="3947008" cy="320040"/>
-          </a:xfrm>
-          <a:prstGeom prst="rect">
-            <a:avLst/>
-          </a:prstGeom>
-          <a:noFill/>
-          <a:ln/>
-        </p:spPr>
-        <p:txBody>
-          <a:bodyPr wrap="square" rtlCol="0" anchor="ctr"/>
-          <a:lstStyle/>
-          <a:p>
-            <a:pPr indent="0" marL="0">
-              <a:buNone/>
-            </a:pPr>
-            <a:r>
-              <a:rPr lang="en-US" sz="1250" b="1" spc="100" kern="0" dirty="0">
-                <a:solidFill>
-                  <a:srgbClr val="47602D"/>
-                </a:solidFill>
-                <a:latin typeface="Calibri" pitchFamily="34" charset="0"/>
-                <a:ea typeface="Calibri" pitchFamily="34" charset="-122"/>
-                <a:cs typeface="Calibri" pitchFamily="34" charset="-120"/>
-              </a:rPr>
-              <a:t>Shipping</a:t>
-            </a:r>
-            <a:endParaRPr lang="en-US" sz="1250" dirty="0"/>
-          </a:p>
-        </p:txBody>
-      </p:sp>
-      <p:sp>
-        <p:nvSpPr>
-          <p:cNvPr id="25" name="Text 23"/>
-          <p:cNvSpPr/>
-          <p:nvPr/>
-        </p:nvSpPr>
-        <p:spPr>
-          <a:xfrm>
-            <a:off x="7421728" y="3913632"/>
-            <a:ext cx="3901288" cy="594360"/>
-          </a:xfrm>
-          <a:prstGeom prst="rect">
-            <a:avLst/>
-          </a:prstGeom>
-          <a:noFill/>
-          <a:ln/>
-        </p:spPr>
-        <p:txBody>
-          <a:bodyPr wrap="square" rtlCol="0" anchor="t"/>
-          <a:lstStyle/>
-          <a:p>
-            <a:pPr indent="0" marL="0">
-              <a:buNone/>
-            </a:pPr>
-            <a:r>
-              <a:rPr lang="en-US" sz="1200" dirty="0">
-                <a:solidFill>
-                  <a:srgbClr val="2C332A"/>
-                </a:solidFill>
-                <a:latin typeface="Calibri" pitchFamily="34" charset="0"/>
-                <a:ea typeface="Calibri" pitchFamily="34" charset="-122"/>
-                <a:cs typeface="Calibri" pitchFamily="34" charset="-120"/>
-              </a:rPr>
-              <a:t>Finished (Singapore): DDP, free over S$800   ·   Bulk: FOB Japan</a:t>
-            </a:r>
-            <a:endParaRPr lang="en-US" sz="1200" dirty="0"/>
-          </a:p>
-        </p:txBody>
-      </p:sp>
-      <p:sp>
-        <p:nvSpPr>
-          <p:cNvPr id="26" name="Shape 24"/>
-          <p:cNvSpPr/>
-          <p:nvPr/>
-        </p:nvSpPr>
-        <p:spPr>
-          <a:xfrm>
-            <a:off x="640080" y="4809744"/>
-            <a:ext cx="5227168" cy="1188720"/>
-          </a:xfrm>
-          <a:prstGeom prst="roundRect">
-            <a:avLst>
-              <a:gd name="adj" fmla="val 6154"/>
-            </a:avLst>
-          </a:prstGeom>
-          <a:solidFill>
-            <a:srgbClr val="F6F4EC"/>
-          </a:solidFill>
-          <a:ln w="12700">
-            <a:solidFill>
-              <a:srgbClr val="E2DFD4"/>
-            </a:solidFill>
-            <a:prstDash val="solid"/>
-          </a:ln>
-        </p:spPr>
-      </p:sp>
-      <p:sp>
-        <p:nvSpPr>
-          <p:cNvPr id="27" name="Shape 25"/>
-          <p:cNvSpPr/>
-          <p:nvPr/>
-        </p:nvSpPr>
-        <p:spPr>
-          <a:xfrm>
-            <a:off x="960120" y="5129784"/>
-            <a:ext cx="566928" cy="566928"/>
-          </a:xfrm>
-          <a:prstGeom prst="ellipse">
-            <a:avLst/>
-          </a:prstGeom>
-          <a:solidFill>
-            <a:srgbClr val="5E7A3C"/>
-          </a:solidFill>
-          <a:ln/>
-        </p:spPr>
-      </p:sp>
-      <p:sp>
-        <p:nvSpPr>
-          <p:cNvPr id="28" name="Text 26"/>
-          <p:cNvSpPr/>
-          <p:nvPr/>
-        </p:nvSpPr>
-        <p:spPr>
-          <a:xfrm>
-            <a:off x="960120" y="5129784"/>
-            <a:ext cx="566928" cy="566928"/>
-          </a:xfrm>
-          <a:prstGeom prst="rect">
-            <a:avLst/>
-          </a:prstGeom>
-          <a:noFill/>
-          <a:ln/>
-        </p:spPr>
-        <p:txBody>
-          <a:bodyPr wrap="square" rtlCol="0" anchor="ctr"/>
-          <a:lstStyle/>
-          <a:p>
-            <a:pPr algn="ctr" indent="0" marL="0">
-              <a:buNone/>
-            </a:pPr>
-            <a:r>
-              <a:rPr lang="en-US" sz="2200" b="1" dirty="0">
-                <a:solidFill>
-                  <a:srgbClr val="FFFFFF"/>
-                </a:solidFill>
-                <a:latin typeface="Cambria" pitchFamily="34" charset="0"/>
-                <a:ea typeface="Cambria" pitchFamily="34" charset="-122"/>
-                <a:cs typeface="Cambria" pitchFamily="34" charset="-120"/>
-              </a:rPr>
-              <a:t>P</a:t>
-            </a:r>
-            <a:endParaRPr lang="en-US" sz="2200" dirty="0"/>
-          </a:p>
-        </p:txBody>
-      </p:sp>
-      <p:sp>
-        <p:nvSpPr>
-          <p:cNvPr id="29" name="Text 27"/>
-          <p:cNvSpPr/>
-          <p:nvPr/>
-        </p:nvSpPr>
-        <p:spPr>
-          <a:xfrm>
-            <a:off x="1737360" y="5029200"/>
-            <a:ext cx="3947008" cy="320040"/>
-          </a:xfrm>
-          <a:prstGeom prst="rect">
-            <a:avLst/>
-          </a:prstGeom>
-          <a:noFill/>
-          <a:ln/>
-        </p:spPr>
-        <p:txBody>
-          <a:bodyPr wrap="square" rtlCol="0" anchor="ctr"/>
-          <a:lstStyle/>
-          <a:p>
-            <a:pPr indent="0" marL="0">
-              <a:buNone/>
-            </a:pPr>
-            <a:r>
-              <a:rPr lang="en-US" sz="1250" b="1" spc="100" kern="0" dirty="0">
-                <a:solidFill>
-                  <a:srgbClr val="47602D"/>
-                </a:solidFill>
-                <a:latin typeface="Calibri" pitchFamily="34" charset="0"/>
-                <a:ea typeface="Calibri" pitchFamily="34" charset="-122"/>
-                <a:cs typeface="Calibri" pitchFamily="34" charset="-120"/>
-              </a:rPr>
-              <a:t>Payment</a:t>
-            </a:r>
-            <a:endParaRPr lang="en-US" sz="1250" dirty="0"/>
-          </a:p>
-        </p:txBody>
-      </p:sp>
-      <p:sp>
-        <p:nvSpPr>
-          <p:cNvPr id="30" name="Text 28"/>
-          <p:cNvSpPr/>
-          <p:nvPr/>
-        </p:nvSpPr>
-        <p:spPr>
-          <a:xfrm>
-            <a:off x="1737360" y="5358384"/>
-            <a:ext cx="3901288" cy="594360"/>
-          </a:xfrm>
-          <a:prstGeom prst="rect">
-            <a:avLst/>
-          </a:prstGeom>
-          <a:noFill/>
-          <a:ln/>
-        </p:spPr>
-        <p:txBody>
-          <a:bodyPr wrap="square" rtlCol="0" anchor="t"/>
-          <a:lstStyle/>
-          <a:p>
-            <a:pPr indent="0" marL="0">
-              <a:buNone/>
-            </a:pPr>
-            <a:r>
-              <a:rPr lang="en-US" sz="1200" dirty="0">
-                <a:solidFill>
-                  <a:srgbClr val="2C332A"/>
-                </a:solidFill>
-                <a:latin typeface="Calibri" pitchFamily="34" charset="0"/>
-                <a:ea typeface="Calibri" pitchFamily="34" charset="-122"/>
-                <a:cs typeface="Calibri" pitchFamily="34" charset="-120"/>
-              </a:rPr>
-              <a:t>Advance payment (T/T) — production begins on confirmation</a:t>
-            </a:r>
-            <a:endParaRPr lang="en-US" sz="1200" dirty="0"/>
-          </a:p>
-        </p:txBody>
-      </p:sp>
-      <p:sp>
-        <p:nvSpPr>
-          <p:cNvPr id="31" name="Shape 29"/>
-          <p:cNvSpPr/>
-          <p:nvPr/>
-        </p:nvSpPr>
-        <p:spPr>
-          <a:xfrm>
-            <a:off x="6324448" y="4809744"/>
-            <a:ext cx="5227168" cy="1188720"/>
-          </a:xfrm>
-          <a:prstGeom prst="roundRect">
-            <a:avLst>
-              <a:gd name="adj" fmla="val 6154"/>
-            </a:avLst>
-          </a:prstGeom>
-          <a:solidFill>
-            <a:srgbClr val="F6F4EC"/>
-          </a:solidFill>
-          <a:ln w="12700">
-            <a:solidFill>
-              <a:srgbClr val="E2DFD4"/>
-            </a:solidFill>
-            <a:prstDash val="solid"/>
-          </a:ln>
-        </p:spPr>
-      </p:sp>
-      <p:sp>
-        <p:nvSpPr>
-          <p:cNvPr id="32" name="Shape 30"/>
-          <p:cNvSpPr/>
-          <p:nvPr/>
-        </p:nvSpPr>
-        <p:spPr>
-          <a:xfrm>
-            <a:off x="6644488" y="5129784"/>
-            <a:ext cx="566928" cy="566928"/>
-          </a:xfrm>
-          <a:prstGeom prst="ellipse">
-            <a:avLst/>
-          </a:prstGeom>
-          <a:solidFill>
-            <a:srgbClr val="5E7A3C"/>
-          </a:solidFill>
-          <a:ln/>
-        </p:spPr>
-      </p:sp>
-      <p:sp>
-        <p:nvSpPr>
-          <p:cNvPr id="33" name="Text 31"/>
-          <p:cNvSpPr/>
-          <p:nvPr/>
-        </p:nvSpPr>
-        <p:spPr>
-          <a:xfrm>
-            <a:off x="6644488" y="5129784"/>
-            <a:ext cx="566928" cy="566928"/>
-          </a:xfrm>
-          <a:prstGeom prst="rect">
-            <a:avLst/>
-          </a:prstGeom>
-          <a:noFill/>
-          <a:ln/>
-        </p:spPr>
-        <p:txBody>
-          <a:bodyPr wrap="square" rtlCol="0" anchor="ctr"/>
-          <a:lstStyle/>
-          <a:p>
-            <a:pPr algn="ctr" indent="0" marL="0">
-              <a:buNone/>
-            </a:pPr>
-            <a:r>
-              <a:rPr lang="en-US" sz="2200" b="1" dirty="0">
-                <a:solidFill>
-                  <a:srgbClr val="FFFFFF"/>
-                </a:solidFill>
-                <a:latin typeface="Cambria" pitchFamily="34" charset="0"/>
-                <a:ea typeface="Cambria" pitchFamily="34" charset="-122"/>
-                <a:cs typeface="Cambria" pitchFamily="34" charset="-120"/>
-              </a:rPr>
-              <a:t>S</a:t>
-            </a:r>
-            <a:endParaRPr lang="en-US" sz="2200" dirty="0"/>
-          </a:p>
-        </p:txBody>
-      </p:sp>
-      <p:sp>
-        <p:nvSpPr>
-          <p:cNvPr id="34" name="Text 32"/>
-          <p:cNvSpPr/>
-          <p:nvPr/>
-        </p:nvSpPr>
-        <p:spPr>
-          <a:xfrm>
-            <a:off x="7421728" y="5029200"/>
-            <a:ext cx="3947008" cy="320040"/>
-          </a:xfrm>
-          <a:prstGeom prst="rect">
-            <a:avLst/>
-          </a:prstGeom>
-          <a:noFill/>
-          <a:ln/>
-        </p:spPr>
-        <p:txBody>
-          <a:bodyPr wrap="square" rtlCol="0" anchor="ctr"/>
-          <a:lstStyle/>
-          <a:p>
-            <a:pPr indent="0" marL="0">
-              <a:buNone/>
-            </a:pPr>
-            <a:r>
-              <a:rPr lang="en-US" sz="1250" b="1" spc="100" kern="0" dirty="0">
-                <a:solidFill>
-                  <a:srgbClr val="47602D"/>
-                </a:solidFill>
-                <a:latin typeface="Calibri" pitchFamily="34" charset="0"/>
-                <a:ea typeface="Calibri" pitchFamily="34" charset="-122"/>
-                <a:cs typeface="Calibri" pitchFamily="34" charset="-120"/>
-              </a:rPr>
-              <a:t>Samples</a:t>
-            </a:r>
-            <a:endParaRPr lang="en-US" sz="1250" dirty="0"/>
-          </a:p>
-        </p:txBody>
-      </p:sp>
-      <p:sp>
-        <p:nvSpPr>
-          <p:cNvPr id="35" name="Text 33"/>
-          <p:cNvSpPr/>
-          <p:nvPr/>
-        </p:nvSpPr>
-        <p:spPr>
-          <a:xfrm>
-            <a:off x="7421728" y="5358384"/>
-            <a:ext cx="3901288" cy="594360"/>
-          </a:xfrm>
-          <a:prstGeom prst="rect">
-            <a:avLst/>
-          </a:prstGeom>
-          <a:noFill/>
-          <a:ln/>
-        </p:spPr>
-        <p:txBody>
-          <a:bodyPr wrap="square" rtlCol="0" anchor="t"/>
-          <a:lstStyle/>
-          <a:p>
-            <a:pPr indent="0" marL="0">
-              <a:buNone/>
-            </a:pPr>
-            <a:r>
-              <a:rPr lang="en-US" sz="1200" dirty="0">
-                <a:solidFill>
-                  <a:srgbClr val="2C332A"/>
-                </a:solidFill>
-                <a:latin typeface="Calibri" pitchFamily="34" charset="0"/>
-                <a:ea typeface="Calibri" pitchFamily="34" charset="-122"/>
-                <a:cs typeface="Calibri" pitchFamily="34" charset="-120"/>
-              </a:rPr>
-              <a:t>Complimentary for qualified buyers</a:t>
-            </a:r>
-            <a:endParaRPr lang="en-US" sz="1200" dirty="0"/>
-          </a:p>
-        </p:txBody>
-      </p:sp>
-      <p:sp>
-        <p:nvSpPr>
-          <p:cNvPr id="36" name="Text 34"/>
-          <p:cNvSpPr/>
-          <p:nvPr/>
-        </p:nvSpPr>
-        <p:spPr>
-          <a:xfrm>
-            <a:off x="640080" y="6053328"/>
-            <a:ext cx="10515600" cy="274320"/>
-          </a:xfrm>
-          <a:prstGeom prst="rect">
-            <a:avLst/>
-          </a:prstGeom>
-          <a:noFill/>
-          <a:ln/>
-        </p:spPr>
-        <p:txBody>
-          <a:bodyPr wrap="square" rtlCol="0" anchor="ctr"/>
-          <a:lstStyle/>
-          <a:p>
-            <a:pPr indent="0" marL="0">
-              <a:buNone/>
-            </a:pPr>
-            <a:r>
-              <a:rPr lang="en-US" sz="1050" i="1" dirty="0">
-                <a:solidFill>
-                  <a:srgbClr val="70776B"/>
-                </a:solidFill>
-                <a:latin typeface="Calibri" pitchFamily="34" charset="0"/>
-                <a:ea typeface="Calibri" pitchFamily="34" charset="-122"/>
-                <a:cs typeface="Calibri" pitchFamily="34" charset="-120"/>
-              </a:rPr>
-              <a:t>All prices in SGD, subject to FX.</a:t>
-            </a:r>
-            <a:endParaRPr lang="en-US" sz="1050" dirty="0"/>
-          </a:p>
-        </p:txBody>
-      </p:sp>
-      <p:sp>
-        <p:nvSpPr>
-          <p:cNvPr id="37" name="Text 35"/>
-          <p:cNvSpPr/>
-          <p:nvPr/>
-        </p:nvSpPr>
-        <p:spPr>
-          <a:xfrm>
-            <a:off x="640080" y="6400800"/>
-            <a:ext cx="5486400" cy="274320"/>
-          </a:xfrm>
-          <a:prstGeom prst="rect">
-            <a:avLst/>
-          </a:prstGeom>
-          <a:noFill/>
-          <a:ln/>
-        </p:spPr>
-        <p:txBody>
-          <a:bodyPr wrap="square" rtlCol="0" anchor="ctr"/>
-          <a:lstStyle/>
-          <a:p>
-            <a:pPr algn="l" indent="0" marL="0">
-              <a:buNone/>
-            </a:pPr>
-            <a:r>
-              <a:rPr lang="en-US" sz="900" dirty="0">
-                <a:solidFill>
-                  <a:srgbClr val="70776B"/>
-                </a:solidFill>
-                <a:latin typeface="Calibri" pitchFamily="34" charset="0"/>
-                <a:ea typeface="Calibri" pitchFamily="34" charset="-122"/>
-                <a:cs typeface="Calibri" pitchFamily="34" charset="-120"/>
-              </a:rPr>
-              <a:t>SHIZUNE MATCHA  ·  Traverse Asia</a:t>
-            </a:r>
-            <a:endParaRPr lang="en-US" sz="900" dirty="0"/>
-          </a:p>
-        </p:txBody>
-      </p:sp>
-      <p:sp>
-        <p:nvSpPr>
-          <p:cNvPr id="38" name="Text 36"/>
           <p:cNvSpPr/>
           <p:nvPr/>
         </p:nvSpPr>

</xml_diff>